<commit_message>
Update TL1 Lecture One 20260910 REV1.pptx
Added slide
</commit_message>
<xml_diff>
--- a/docs/TL1-Adam/TL1 Lecture One 20260910 REV1.pptx
+++ b/docs/TL1-Adam/TL1 Lecture One 20260910 REV1.pptx
@@ -5,31 +5,32 @@
     <p:sldMasterId id="2147483648" r:id="rId1"/>
   </p:sldMasterIdLst>
   <p:notesMasterIdLst>
-    <p:notesMasterId r:id="rId24"/>
+    <p:notesMasterId r:id="rId25"/>
   </p:notesMasterIdLst>
   <p:sldIdLst>
     <p:sldId id="256" r:id="rId2"/>
-    <p:sldId id="257" r:id="rId3"/>
-    <p:sldId id="258" r:id="rId4"/>
-    <p:sldId id="259" r:id="rId5"/>
-    <p:sldId id="260" r:id="rId6"/>
-    <p:sldId id="261" r:id="rId7"/>
-    <p:sldId id="269" r:id="rId8"/>
-    <p:sldId id="270" r:id="rId9"/>
-    <p:sldId id="271" r:id="rId10"/>
-    <p:sldId id="266" r:id="rId11"/>
-    <p:sldId id="272" r:id="rId12"/>
-    <p:sldId id="273" r:id="rId13"/>
-    <p:sldId id="274" r:id="rId14"/>
-    <p:sldId id="275" r:id="rId15"/>
-    <p:sldId id="276" r:id="rId16"/>
-    <p:sldId id="277" r:id="rId17"/>
-    <p:sldId id="278" r:id="rId18"/>
-    <p:sldId id="264" r:id="rId19"/>
-    <p:sldId id="279" r:id="rId20"/>
-    <p:sldId id="265" r:id="rId21"/>
-    <p:sldId id="267" r:id="rId22"/>
-    <p:sldId id="268" r:id="rId23"/>
+    <p:sldId id="280" r:id="rId3"/>
+    <p:sldId id="257" r:id="rId4"/>
+    <p:sldId id="258" r:id="rId5"/>
+    <p:sldId id="259" r:id="rId6"/>
+    <p:sldId id="260" r:id="rId7"/>
+    <p:sldId id="261" r:id="rId8"/>
+    <p:sldId id="269" r:id="rId9"/>
+    <p:sldId id="270" r:id="rId10"/>
+    <p:sldId id="271" r:id="rId11"/>
+    <p:sldId id="266" r:id="rId12"/>
+    <p:sldId id="272" r:id="rId13"/>
+    <p:sldId id="273" r:id="rId14"/>
+    <p:sldId id="274" r:id="rId15"/>
+    <p:sldId id="275" r:id="rId16"/>
+    <p:sldId id="276" r:id="rId17"/>
+    <p:sldId id="277" r:id="rId18"/>
+    <p:sldId id="278" r:id="rId19"/>
+    <p:sldId id="264" r:id="rId20"/>
+    <p:sldId id="279" r:id="rId21"/>
+    <p:sldId id="265" r:id="rId22"/>
+    <p:sldId id="267" r:id="rId23"/>
+    <p:sldId id="268" r:id="rId24"/>
   </p:sldIdLst>
   <p:sldSz cx="9144000" cy="6858000" type="screen4x3"/>
   <p:notesSz cx="6858000" cy="9144000"/>
@@ -232,6 +233,64 @@
     </pc:docChg>
   </pc:docChgLst>
   <pc:docChgLst>
+    <pc:chgData name="Crane, Dawson (cran3111@vandals.uidaho.edu)" userId="S::cran3111@vandals.uidaho.edu::ef316378-d886-46b1-9f2b-6bd582f24de9" providerId="AD" clId="Web-{36267CCB-8284-2D65-E6D3-FDAE159E3817}"/>
+    <pc:docChg chg="addSld delSld">
+      <pc:chgData name="Crane, Dawson (cran3111@vandals.uidaho.edu)" userId="S::cran3111@vandals.uidaho.edu::ef316378-d886-46b1-9f2b-6bd582f24de9" providerId="AD" clId="Web-{36267CCB-8284-2D65-E6D3-FDAE159E3817}" dt="2026-09-07T01:21:15.696" v="8"/>
+      <pc:docMkLst>
+        <pc:docMk/>
+      </pc:docMkLst>
+      <pc:sldChg chg="add">
+        <pc:chgData name="Crane, Dawson (cran3111@vandals.uidaho.edu)" userId="S::cran3111@vandals.uidaho.edu::ef316378-d886-46b1-9f2b-6bd582f24de9" providerId="AD" clId="Web-{36267CCB-8284-2D65-E6D3-FDAE159E3817}" dt="2026-09-07T01:20:51.790" v="0"/>
+        <pc:sldMkLst>
+          <pc:docMk/>
+          <pc:sldMk cId="1884988539" sldId="272"/>
+        </pc:sldMkLst>
+      </pc:sldChg>
+      <pc:sldChg chg="add">
+        <pc:chgData name="Crane, Dawson (cran3111@vandals.uidaho.edu)" userId="S::cran3111@vandals.uidaho.edu::ef316378-d886-46b1-9f2b-6bd582f24de9" providerId="AD" clId="Web-{36267CCB-8284-2D65-E6D3-FDAE159E3817}" dt="2026-09-07T01:20:51.837" v="1"/>
+        <pc:sldMkLst>
+          <pc:docMk/>
+          <pc:sldMk cId="3804593003" sldId="273"/>
+        </pc:sldMkLst>
+      </pc:sldChg>
+      <pc:sldChg chg="add">
+        <pc:chgData name="Crane, Dawson (cran3111@vandals.uidaho.edu)" userId="S::cran3111@vandals.uidaho.edu::ef316378-d886-46b1-9f2b-6bd582f24de9" providerId="AD" clId="Web-{36267CCB-8284-2D65-E6D3-FDAE159E3817}" dt="2026-09-07T01:20:51.884" v="2"/>
+        <pc:sldMkLst>
+          <pc:docMk/>
+          <pc:sldMk cId="1902343457" sldId="274"/>
+        </pc:sldMkLst>
+      </pc:sldChg>
+      <pc:sldChg chg="add">
+        <pc:chgData name="Crane, Dawson (cran3111@vandals.uidaho.edu)" userId="S::cran3111@vandals.uidaho.edu::ef316378-d886-46b1-9f2b-6bd582f24de9" providerId="AD" clId="Web-{36267CCB-8284-2D65-E6D3-FDAE159E3817}" dt="2026-09-07T01:20:51.931" v="3"/>
+        <pc:sldMkLst>
+          <pc:docMk/>
+          <pc:sldMk cId="3580135882" sldId="275"/>
+        </pc:sldMkLst>
+      </pc:sldChg>
+      <pc:sldChg chg="add">
+        <pc:chgData name="Crane, Dawson (cran3111@vandals.uidaho.edu)" userId="S::cran3111@vandals.uidaho.edu::ef316378-d886-46b1-9f2b-6bd582f24de9" providerId="AD" clId="Web-{36267CCB-8284-2D65-E6D3-FDAE159E3817}" dt="2026-09-07T01:20:51.978" v="4"/>
+        <pc:sldMkLst>
+          <pc:docMk/>
+          <pc:sldMk cId="269738178" sldId="276"/>
+        </pc:sldMkLst>
+      </pc:sldChg>
+      <pc:sldChg chg="add">
+        <pc:chgData name="Crane, Dawson (cran3111@vandals.uidaho.edu)" userId="S::cran3111@vandals.uidaho.edu::ef316378-d886-46b1-9f2b-6bd582f24de9" providerId="AD" clId="Web-{36267CCB-8284-2D65-E6D3-FDAE159E3817}" dt="2026-09-07T01:20:52.025" v="5"/>
+        <pc:sldMkLst>
+          <pc:docMk/>
+          <pc:sldMk cId="3484678518" sldId="277"/>
+        </pc:sldMkLst>
+      </pc:sldChg>
+      <pc:sldChg chg="add">
+        <pc:chgData name="Crane, Dawson (cran3111@vandals.uidaho.edu)" userId="S::cran3111@vandals.uidaho.edu::ef316378-d886-46b1-9f2b-6bd582f24de9" providerId="AD" clId="Web-{36267CCB-8284-2D65-E6D3-FDAE159E3817}" dt="2026-09-07T01:21:14.337" v="7"/>
+        <pc:sldMkLst>
+          <pc:docMk/>
+          <pc:sldMk cId="157008958" sldId="278"/>
+        </pc:sldMkLst>
+      </pc:sldChg>
+    </pc:docChg>
+  </pc:docChgLst>
+  <pc:docChgLst>
     <pc:chgData name="Sinipete, Breana (sini2348@vandals.uidaho.edu)" userId="f688145d-2fb5-4953-9054-1b32162b0f5b" providerId="ADAL" clId="{ABAB2BBD-0ACF-46CF-852A-D4D6951A9502}"/>
     <pc:docChg chg="custSel addSld modSld">
       <pc:chgData name="Sinipete, Breana (sini2348@vandals.uidaho.edu)" userId="f688145d-2fb5-4953-9054-1b32162b0f5b" providerId="ADAL" clId="{ABAB2BBD-0ACF-46CF-852A-D4D6951A9502}" dt="2026-09-09T23:20:24.781" v="30" actId="115"/>
@@ -305,64 +364,6 @@
             <ac:picMk id="8" creationId="{59122ADE-7C81-D869-E170-852F87B84E63}"/>
           </ac:picMkLst>
         </pc:picChg>
-      </pc:sldChg>
-    </pc:docChg>
-  </pc:docChgLst>
-  <pc:docChgLst>
-    <pc:chgData name="Crane, Dawson (cran3111@vandals.uidaho.edu)" userId="S::cran3111@vandals.uidaho.edu::ef316378-d886-46b1-9f2b-6bd582f24de9" providerId="AD" clId="Web-{36267CCB-8284-2D65-E6D3-FDAE159E3817}"/>
-    <pc:docChg chg="addSld delSld">
-      <pc:chgData name="Crane, Dawson (cran3111@vandals.uidaho.edu)" userId="S::cran3111@vandals.uidaho.edu::ef316378-d886-46b1-9f2b-6bd582f24de9" providerId="AD" clId="Web-{36267CCB-8284-2D65-E6D3-FDAE159E3817}" dt="2026-09-07T01:21:15.696" v="8"/>
-      <pc:docMkLst>
-        <pc:docMk/>
-      </pc:docMkLst>
-      <pc:sldChg chg="add">
-        <pc:chgData name="Crane, Dawson (cran3111@vandals.uidaho.edu)" userId="S::cran3111@vandals.uidaho.edu::ef316378-d886-46b1-9f2b-6bd582f24de9" providerId="AD" clId="Web-{36267CCB-8284-2D65-E6D3-FDAE159E3817}" dt="2026-09-07T01:20:51.790" v="0"/>
-        <pc:sldMkLst>
-          <pc:docMk/>
-          <pc:sldMk cId="1884988539" sldId="272"/>
-        </pc:sldMkLst>
-      </pc:sldChg>
-      <pc:sldChg chg="add">
-        <pc:chgData name="Crane, Dawson (cran3111@vandals.uidaho.edu)" userId="S::cran3111@vandals.uidaho.edu::ef316378-d886-46b1-9f2b-6bd582f24de9" providerId="AD" clId="Web-{36267CCB-8284-2D65-E6D3-FDAE159E3817}" dt="2026-09-07T01:20:51.837" v="1"/>
-        <pc:sldMkLst>
-          <pc:docMk/>
-          <pc:sldMk cId="3804593003" sldId="273"/>
-        </pc:sldMkLst>
-      </pc:sldChg>
-      <pc:sldChg chg="add">
-        <pc:chgData name="Crane, Dawson (cran3111@vandals.uidaho.edu)" userId="S::cran3111@vandals.uidaho.edu::ef316378-d886-46b1-9f2b-6bd582f24de9" providerId="AD" clId="Web-{36267CCB-8284-2D65-E6D3-FDAE159E3817}" dt="2026-09-07T01:20:51.884" v="2"/>
-        <pc:sldMkLst>
-          <pc:docMk/>
-          <pc:sldMk cId="1902343457" sldId="274"/>
-        </pc:sldMkLst>
-      </pc:sldChg>
-      <pc:sldChg chg="add">
-        <pc:chgData name="Crane, Dawson (cran3111@vandals.uidaho.edu)" userId="S::cran3111@vandals.uidaho.edu::ef316378-d886-46b1-9f2b-6bd582f24de9" providerId="AD" clId="Web-{36267CCB-8284-2D65-E6D3-FDAE159E3817}" dt="2026-09-07T01:20:51.931" v="3"/>
-        <pc:sldMkLst>
-          <pc:docMk/>
-          <pc:sldMk cId="3580135882" sldId="275"/>
-        </pc:sldMkLst>
-      </pc:sldChg>
-      <pc:sldChg chg="add">
-        <pc:chgData name="Crane, Dawson (cran3111@vandals.uidaho.edu)" userId="S::cran3111@vandals.uidaho.edu::ef316378-d886-46b1-9f2b-6bd582f24de9" providerId="AD" clId="Web-{36267CCB-8284-2D65-E6D3-FDAE159E3817}" dt="2026-09-07T01:20:51.978" v="4"/>
-        <pc:sldMkLst>
-          <pc:docMk/>
-          <pc:sldMk cId="269738178" sldId="276"/>
-        </pc:sldMkLst>
-      </pc:sldChg>
-      <pc:sldChg chg="add">
-        <pc:chgData name="Crane, Dawson (cran3111@vandals.uidaho.edu)" userId="S::cran3111@vandals.uidaho.edu::ef316378-d886-46b1-9f2b-6bd582f24de9" providerId="AD" clId="Web-{36267CCB-8284-2D65-E6D3-FDAE159E3817}" dt="2026-09-07T01:20:52.025" v="5"/>
-        <pc:sldMkLst>
-          <pc:docMk/>
-          <pc:sldMk cId="3484678518" sldId="277"/>
-        </pc:sldMkLst>
-      </pc:sldChg>
-      <pc:sldChg chg="add">
-        <pc:chgData name="Crane, Dawson (cran3111@vandals.uidaho.edu)" userId="S::cran3111@vandals.uidaho.edu::ef316378-d886-46b1-9f2b-6bd582f24de9" providerId="AD" clId="Web-{36267CCB-8284-2D65-E6D3-FDAE159E3817}" dt="2026-09-07T01:21:14.337" v="7"/>
-        <pc:sldMkLst>
-          <pc:docMk/>
-          <pc:sldMk cId="157008958" sldId="278"/>
-        </pc:sldMkLst>
       </pc:sldChg>
     </pc:docChg>
   </pc:docChgLst>
@@ -523,60 +524,6 @@
             <pc:docMk/>
             <pc:sldMk cId="0" sldId="268"/>
             <ac:spMk id="4" creationId="{BA49BD22-11DE-4556-E9E4-720C59FC692D}"/>
-          </ac:spMkLst>
-        </pc:spChg>
-      </pc:sldChg>
-    </pc:docChg>
-  </pc:docChgLst>
-  <pc:docChgLst>
-    <pc:chgData name="Bailey, Christopher (bail6984@vandals.uidaho.edu)" userId="S::bail6984@vandals.uidaho.edu::964264a4-dc50-4db0-bd46-111b8bd241da" providerId="AD" clId="Web-{9C1381D8-F1E3-83AC-35F2-9BEA6A586904}"/>
-    <pc:docChg chg="modSld">
-      <pc:chgData name="Bailey, Christopher (bail6984@vandals.uidaho.edu)" userId="S::bail6984@vandals.uidaho.edu::964264a4-dc50-4db0-bd46-111b8bd241da" providerId="AD" clId="Web-{9C1381D8-F1E3-83AC-35F2-9BEA6A586904}" dt="2026-09-10T00:46:28.478" v="19" actId="20577"/>
-      <pc:docMkLst>
-        <pc:docMk/>
-      </pc:docMkLst>
-      <pc:sldChg chg="modSp">
-        <pc:chgData name="Bailey, Christopher (bail6984@vandals.uidaho.edu)" userId="S::bail6984@vandals.uidaho.edu::964264a4-dc50-4db0-bd46-111b8bd241da" providerId="AD" clId="Web-{9C1381D8-F1E3-83AC-35F2-9BEA6A586904}" dt="2026-09-10T00:46:28.478" v="19" actId="20577"/>
-        <pc:sldMkLst>
-          <pc:docMk/>
-          <pc:sldMk cId="3070233841" sldId="269"/>
-        </pc:sldMkLst>
-        <pc:spChg chg="mod">
-          <ac:chgData name="Bailey, Christopher (bail6984@vandals.uidaho.edu)" userId="S::bail6984@vandals.uidaho.edu::964264a4-dc50-4db0-bd46-111b8bd241da" providerId="AD" clId="Web-{9C1381D8-F1E3-83AC-35F2-9BEA6A586904}" dt="2026-09-10T00:46:28.478" v="19" actId="20577"/>
-          <ac:spMkLst>
-            <pc:docMk/>
-            <pc:sldMk cId="3070233841" sldId="269"/>
-            <ac:spMk id="3" creationId="{5D997EAF-683B-C0C2-DD2A-82EC1635AA77}"/>
-          </ac:spMkLst>
-        </pc:spChg>
-      </pc:sldChg>
-      <pc:sldChg chg="modSp">
-        <pc:chgData name="Bailey, Christopher (bail6984@vandals.uidaho.edu)" userId="S::bail6984@vandals.uidaho.edu::964264a4-dc50-4db0-bd46-111b8bd241da" providerId="AD" clId="Web-{9C1381D8-F1E3-83AC-35F2-9BEA6A586904}" dt="2026-09-10T00:41:41.762" v="10" actId="20577"/>
-        <pc:sldMkLst>
-          <pc:docMk/>
-          <pc:sldMk cId="188840435" sldId="270"/>
-        </pc:sldMkLst>
-        <pc:spChg chg="mod">
-          <ac:chgData name="Bailey, Christopher (bail6984@vandals.uidaho.edu)" userId="S::bail6984@vandals.uidaho.edu::964264a4-dc50-4db0-bd46-111b8bd241da" providerId="AD" clId="Web-{9C1381D8-F1E3-83AC-35F2-9BEA6A586904}" dt="2026-09-10T00:41:41.762" v="10" actId="20577"/>
-          <ac:spMkLst>
-            <pc:docMk/>
-            <pc:sldMk cId="188840435" sldId="270"/>
-            <ac:spMk id="3" creationId="{AE6371CF-476B-1EFC-60EA-D20EE7157DBD}"/>
-          </ac:spMkLst>
-        </pc:spChg>
-      </pc:sldChg>
-      <pc:sldChg chg="modSp">
-        <pc:chgData name="Bailey, Christopher (bail6984@vandals.uidaho.edu)" userId="S::bail6984@vandals.uidaho.edu::964264a4-dc50-4db0-bd46-111b8bd241da" providerId="AD" clId="Web-{9C1381D8-F1E3-83AC-35F2-9BEA6A586904}" dt="2026-09-10T00:42:07.871" v="13" actId="20577"/>
-        <pc:sldMkLst>
-          <pc:docMk/>
-          <pc:sldMk cId="2515922887" sldId="271"/>
-        </pc:sldMkLst>
-        <pc:spChg chg="mod">
-          <ac:chgData name="Bailey, Christopher (bail6984@vandals.uidaho.edu)" userId="S::bail6984@vandals.uidaho.edu::964264a4-dc50-4db0-bd46-111b8bd241da" providerId="AD" clId="Web-{9C1381D8-F1E3-83AC-35F2-9BEA6A586904}" dt="2026-09-10T00:42:07.871" v="13" actId="20577"/>
-          <ac:spMkLst>
-            <pc:docMk/>
-            <pc:sldMk cId="2515922887" sldId="271"/>
-            <ac:spMk id="3" creationId="{33347569-8C51-93EA-1945-52269F8EA7AE}"/>
           </ac:spMkLst>
         </pc:spChg>
       </pc:sldChg>
@@ -856,6 +803,60 @@
           </pc:spChg>
         </pc:sldLayoutChg>
       </pc:sldMasterChg>
+    </pc:docChg>
+  </pc:docChgLst>
+  <pc:docChgLst>
+    <pc:chgData name="Bailey, Christopher (bail6984@vandals.uidaho.edu)" userId="S::bail6984@vandals.uidaho.edu::964264a4-dc50-4db0-bd46-111b8bd241da" providerId="AD" clId="Web-{9C1381D8-F1E3-83AC-35F2-9BEA6A586904}"/>
+    <pc:docChg chg="modSld">
+      <pc:chgData name="Bailey, Christopher (bail6984@vandals.uidaho.edu)" userId="S::bail6984@vandals.uidaho.edu::964264a4-dc50-4db0-bd46-111b8bd241da" providerId="AD" clId="Web-{9C1381D8-F1E3-83AC-35F2-9BEA6A586904}" dt="2026-09-10T00:46:28.478" v="19" actId="20577"/>
+      <pc:docMkLst>
+        <pc:docMk/>
+      </pc:docMkLst>
+      <pc:sldChg chg="modSp">
+        <pc:chgData name="Bailey, Christopher (bail6984@vandals.uidaho.edu)" userId="S::bail6984@vandals.uidaho.edu::964264a4-dc50-4db0-bd46-111b8bd241da" providerId="AD" clId="Web-{9C1381D8-F1E3-83AC-35F2-9BEA6A586904}" dt="2026-09-10T00:46:28.478" v="19" actId="20577"/>
+        <pc:sldMkLst>
+          <pc:docMk/>
+          <pc:sldMk cId="3070233841" sldId="269"/>
+        </pc:sldMkLst>
+        <pc:spChg chg="mod">
+          <ac:chgData name="Bailey, Christopher (bail6984@vandals.uidaho.edu)" userId="S::bail6984@vandals.uidaho.edu::964264a4-dc50-4db0-bd46-111b8bd241da" providerId="AD" clId="Web-{9C1381D8-F1E3-83AC-35F2-9BEA6A586904}" dt="2026-09-10T00:46:28.478" v="19" actId="20577"/>
+          <ac:spMkLst>
+            <pc:docMk/>
+            <pc:sldMk cId="3070233841" sldId="269"/>
+            <ac:spMk id="3" creationId="{5D997EAF-683B-C0C2-DD2A-82EC1635AA77}"/>
+          </ac:spMkLst>
+        </pc:spChg>
+      </pc:sldChg>
+      <pc:sldChg chg="modSp">
+        <pc:chgData name="Bailey, Christopher (bail6984@vandals.uidaho.edu)" userId="S::bail6984@vandals.uidaho.edu::964264a4-dc50-4db0-bd46-111b8bd241da" providerId="AD" clId="Web-{9C1381D8-F1E3-83AC-35F2-9BEA6A586904}" dt="2026-09-10T00:41:41.762" v="10" actId="20577"/>
+        <pc:sldMkLst>
+          <pc:docMk/>
+          <pc:sldMk cId="188840435" sldId="270"/>
+        </pc:sldMkLst>
+        <pc:spChg chg="mod">
+          <ac:chgData name="Bailey, Christopher (bail6984@vandals.uidaho.edu)" userId="S::bail6984@vandals.uidaho.edu::964264a4-dc50-4db0-bd46-111b8bd241da" providerId="AD" clId="Web-{9C1381D8-F1E3-83AC-35F2-9BEA6A586904}" dt="2026-09-10T00:41:41.762" v="10" actId="20577"/>
+          <ac:spMkLst>
+            <pc:docMk/>
+            <pc:sldMk cId="188840435" sldId="270"/>
+            <ac:spMk id="3" creationId="{AE6371CF-476B-1EFC-60EA-D20EE7157DBD}"/>
+          </ac:spMkLst>
+        </pc:spChg>
+      </pc:sldChg>
+      <pc:sldChg chg="modSp">
+        <pc:chgData name="Bailey, Christopher (bail6984@vandals.uidaho.edu)" userId="S::bail6984@vandals.uidaho.edu::964264a4-dc50-4db0-bd46-111b8bd241da" providerId="AD" clId="Web-{9C1381D8-F1E3-83AC-35F2-9BEA6A586904}" dt="2026-09-10T00:42:07.871" v="13" actId="20577"/>
+        <pc:sldMkLst>
+          <pc:docMk/>
+          <pc:sldMk cId="2515922887" sldId="271"/>
+        </pc:sldMkLst>
+        <pc:spChg chg="mod">
+          <ac:chgData name="Bailey, Christopher (bail6984@vandals.uidaho.edu)" userId="S::bail6984@vandals.uidaho.edu::964264a4-dc50-4db0-bd46-111b8bd241da" providerId="AD" clId="Web-{9C1381D8-F1E3-83AC-35F2-9BEA6A586904}" dt="2026-09-10T00:42:07.871" v="13" actId="20577"/>
+          <ac:spMkLst>
+            <pc:docMk/>
+            <pc:sldMk cId="2515922887" sldId="271"/>
+            <ac:spMk id="3" creationId="{33347569-8C51-93EA-1945-52269F8EA7AE}"/>
+          </ac:spMkLst>
+        </pc:spChg>
+      </pc:sldChg>
     </pc:docChg>
   </pc:docChgLst>
   <pc:docChgLst>
@@ -6523,7 +6524,13 @@
   <p:cSld>
     <p:spTree>
       <p:nvGrpSpPr>
-        <p:cNvPr id="1" name=""/>
+        <p:cNvPr id="1" name="">
+          <a:extLst>
+            <a:ext uri="{FF2B5EF4-FFF2-40B4-BE49-F238E27FC236}">
+              <a16:creationId xmlns:a16="http://schemas.microsoft.com/office/drawing/2014/main" id="{C39327F6-DFE2-67C3-A81E-95A338315303}"/>
+            </a:ext>
+          </a:extLst>
+        </p:cNvPr>
         <p:cNvGrpSpPr/>
         <p:nvPr/>
       </p:nvGrpSpPr>
@@ -6537,7 +6544,13 @@
       </p:grpSpPr>
       <p:sp>
         <p:nvSpPr>
-          <p:cNvPr id="2" name="Title 1"/>
+          <p:cNvPr id="2" name="Title 1">
+            <a:extLst>
+              <a:ext uri="{FF2B5EF4-FFF2-40B4-BE49-F238E27FC236}">
+                <a16:creationId xmlns:a16="http://schemas.microsoft.com/office/drawing/2014/main" id="{551426AD-7FD5-39AB-8D2E-F718E4E6F1F6}"/>
+              </a:ext>
+            </a:extLst>
+          </p:cNvPr>
           <p:cNvSpPr>
             <a:spLocks noGrp="1"/>
           </p:cNvSpPr>
@@ -6551,14 +6564,21 @@
           <a:lstStyle/>
           <a:p>
             <a:r>
-              <a:t>The Everyday Commands</a:t>
+              <a:rPr lang="en-US"/>
+              <a:t>Recap: Basic GIT commands</a:t>
             </a:r>
           </a:p>
         </p:txBody>
       </p:sp>
       <p:sp>
         <p:nvSpPr>
-          <p:cNvPr id="3" name="Content Placeholder 2"/>
+          <p:cNvPr id="3" name="Content Placeholder 2">
+            <a:extLst>
+              <a:ext uri="{FF2B5EF4-FFF2-40B4-BE49-F238E27FC236}">
+                <a16:creationId xmlns:a16="http://schemas.microsoft.com/office/drawing/2014/main" id="{33347569-8C51-93EA-1945-52269F8EA7AE}"/>
+              </a:ext>
+            </a:extLst>
+          </p:cNvPr>
           <p:cNvSpPr>
             <a:spLocks noGrp="1"/>
           </p:cNvSpPr>
@@ -6566,122 +6586,44 @@
             <p:ph idx="1"/>
           </p:nvPr>
         </p:nvSpPr>
-        <p:spPr>
-          <a:solidFill>
-            <a:schemeClr val="tx1"/>
-          </a:solidFill>
-        </p:spPr>
+        <p:spPr/>
         <p:txBody>
-          <a:bodyPr/>
+          <a:bodyPr vert="horz" lIns="91440" tIns="45720" rIns="91440" bIns="45720" rtlCol="0" anchor="t">
+            <a:normAutofit/>
+          </a:bodyPr>
           <a:lstStyle/>
           <a:p>
-            <a:pPr marL="0" indent="0">
-              <a:buNone/>
-            </a:pPr>
-            <a:r>
-              <a:rPr sz="1600">
-                <a:solidFill>
-                  <a:schemeClr val="bg1"/>
-                </a:solidFill>
-                <a:latin typeface="Consolas"/>
-              </a:rPr>
-              <a:t>git pull                       # get the latest</a:t>
-            </a:r>
-          </a:p>
-          <a:p>
-            <a:pPr marL="0" indent="0">
-              <a:buNone/>
-            </a:pPr>
-            <a:r>
-              <a:rPr sz="1600">
-                <a:solidFill>
-                  <a:schemeClr val="bg1"/>
-                </a:solidFill>
-                <a:latin typeface="Consolas"/>
-              </a:rPr>
-              <a:t># ...add your feature, test it...</a:t>
-            </a:r>
-          </a:p>
-          <a:p>
-            <a:pPr marL="0" indent="0">
-              <a:buNone/>
-            </a:pPr>
-            <a:r>
-              <a:rPr sz="1600">
-                <a:solidFill>
-                  <a:schemeClr val="bg1"/>
-                </a:solidFill>
-                <a:latin typeface="Consolas"/>
-              </a:rPr>
-              <a:t>git add .                      # stage changes</a:t>
-            </a:r>
-          </a:p>
-          <a:p>
-            <a:pPr marL="0" indent="0">
-              <a:buNone/>
-            </a:pPr>
-            <a:r>
-              <a:rPr sz="1600">
-                <a:solidFill>
-                  <a:schemeClr val="bg1"/>
-                </a:solidFill>
-                <a:latin typeface="Consolas"/>
-              </a:rPr>
-              <a:t>git commit -m "Add &lt;feature&gt;"   # save a snapshot</a:t>
-            </a:r>
-          </a:p>
-          <a:p>
-            <a:pPr marL="0" indent="0">
-              <a:buNone/>
-            </a:pPr>
-            <a:r>
-              <a:rPr sz="1600">
-                <a:solidFill>
-                  <a:schemeClr val="bg1"/>
-                </a:solidFill>
-                <a:latin typeface="Consolas"/>
-              </a:rPr>
-              <a:t>git push                       # share with the team</a:t>
-            </a:r>
-          </a:p>
-          <a:p>
-            <a:pPr marL="0" indent="0">
-              <a:buNone/>
-            </a:pPr>
-            <a:endParaRPr sz="1600">
-              <a:solidFill>
-                <a:schemeClr val="bg1"/>
-              </a:solidFill>
-              <a:latin typeface="Consolas"/>
+            <a:r>
+              <a:rPr lang="en-US">
+                <a:ea typeface="Calibri"/>
+                <a:cs typeface="Calibri"/>
+              </a:rPr>
+              <a:t>git push: Sends local commits to the remote repository. </a:t>
+            </a:r>
+          </a:p>
+          <a:p>
+            <a:r>
+              <a:rPr lang="en-US">
+                <a:ea typeface="Calibri"/>
+                <a:cs typeface="Calibri"/>
+              </a:rPr>
+              <a:t>git pull: Fetches new commits from remote branch and merges them with your local branch.</a:t>
+            </a:r>
+          </a:p>
+          <a:p>
+            <a:r>
+              <a:rPr lang="en-US">
+                <a:ea typeface="Calibri"/>
+                <a:cs typeface="Calibri"/>
+              </a:rPr>
+              <a:t>git merge: Takes changes from one branch and integrates them into another branch.</a:t>
+            </a:r>
+          </a:p>
+          <a:p>
+            <a:endParaRPr lang="en-US">
+              <a:ea typeface="Calibri"/>
+              <a:cs typeface="Calibri"/>
             </a:endParaRPr>
-          </a:p>
-          <a:p>
-            <a:pPr marL="0" indent="0">
-              <a:buNone/>
-            </a:pPr>
-            <a:r>
-              <a:rPr sz="1600">
-                <a:solidFill>
-                  <a:schemeClr val="bg1"/>
-                </a:solidFill>
-                <a:latin typeface="Consolas"/>
-              </a:rPr>
-              <a:t># Clear messages: "Add enemy", "Add coins", "Add HUD"</a:t>
-            </a:r>
-          </a:p>
-          <a:p>
-            <a:pPr marL="0" indent="0">
-              <a:buNone/>
-            </a:pPr>
-            <a:r>
-              <a:rPr sz="1600">
-                <a:solidFill>
-                  <a:schemeClr val="bg1"/>
-                </a:solidFill>
-                <a:latin typeface="Consolas"/>
-              </a:rPr>
-              <a:t># so the history reads like the feature list.</a:t>
-            </a:r>
           </a:p>
         </p:txBody>
       </p:sp>
@@ -6690,7 +6632,7 @@
           <p:cNvPr id="4" name="TextBox 3">
             <a:extLst>
               <a:ext uri="{FF2B5EF4-FFF2-40B4-BE49-F238E27FC236}">
-                <a16:creationId xmlns:a16="http://schemas.microsoft.com/office/drawing/2014/main" id="{37AD84AD-7306-691D-96CC-9CF7184D183C}"/>
+                <a16:creationId xmlns:a16="http://schemas.microsoft.com/office/drawing/2014/main" id="{424BBEFF-D94F-BCD7-3F59-E2978F9DD87B}"/>
               </a:ext>
             </a:extLst>
           </p:cNvPr>
@@ -6718,6 +6660,225 @@
                 <a:solidFill>
                   <a:schemeClr val="bg1"/>
                 </a:solidFill>
+              </a:rPr>
+              <a:t>Chris</a:t>
+            </a:r>
+          </a:p>
+        </p:txBody>
+      </p:sp>
+    </p:spTree>
+    <p:extLst>
+      <p:ext uri="{BB962C8B-B14F-4D97-AF65-F5344CB8AC3E}">
+        <p14:creationId xmlns:p14="http://schemas.microsoft.com/office/powerpoint/2010/main" val="2515922887"/>
+      </p:ext>
+    </p:extLst>
+  </p:cSld>
+  <p:clrMapOvr>
+    <a:masterClrMapping/>
+  </p:clrMapOvr>
+</p:sld>
+</file>
+
+<file path=ppt/slides/slide11.xml><?xml version="1.0" encoding="utf-8"?>
+<p:sld xmlns:a="http://schemas.openxmlformats.org/drawingml/2006/main" xmlns:r="http://schemas.openxmlformats.org/officeDocument/2006/relationships" xmlns:p="http://schemas.openxmlformats.org/presentationml/2006/main">
+  <p:cSld>
+    <p:spTree>
+      <p:nvGrpSpPr>
+        <p:cNvPr id="1" name=""/>
+        <p:cNvGrpSpPr/>
+        <p:nvPr/>
+      </p:nvGrpSpPr>
+      <p:grpSpPr>
+        <a:xfrm>
+          <a:off x="0" y="0"/>
+          <a:ext cx="0" cy="0"/>
+          <a:chOff x="0" y="0"/>
+          <a:chExt cx="0" cy="0"/>
+        </a:xfrm>
+      </p:grpSpPr>
+      <p:sp>
+        <p:nvSpPr>
+          <p:cNvPr id="2" name="Title 1"/>
+          <p:cNvSpPr>
+            <a:spLocks noGrp="1"/>
+          </p:cNvSpPr>
+          <p:nvPr>
+            <p:ph type="title"/>
+          </p:nvPr>
+        </p:nvSpPr>
+        <p:spPr/>
+        <p:txBody>
+          <a:bodyPr/>
+          <a:lstStyle/>
+          <a:p>
+            <a:r>
+              <a:t>The Everyday Commands</a:t>
+            </a:r>
+          </a:p>
+        </p:txBody>
+      </p:sp>
+      <p:sp>
+        <p:nvSpPr>
+          <p:cNvPr id="3" name="Content Placeholder 2"/>
+          <p:cNvSpPr>
+            <a:spLocks noGrp="1"/>
+          </p:cNvSpPr>
+          <p:nvPr>
+            <p:ph idx="1"/>
+          </p:nvPr>
+        </p:nvSpPr>
+        <p:spPr>
+          <a:solidFill>
+            <a:schemeClr val="tx1"/>
+          </a:solidFill>
+        </p:spPr>
+        <p:txBody>
+          <a:bodyPr/>
+          <a:lstStyle/>
+          <a:p>
+            <a:pPr marL="0" indent="0">
+              <a:buNone/>
+            </a:pPr>
+            <a:r>
+              <a:rPr sz="1600">
+                <a:solidFill>
+                  <a:schemeClr val="bg1"/>
+                </a:solidFill>
+                <a:latin typeface="Consolas"/>
+              </a:rPr>
+              <a:t>git pull                       # get the latest</a:t>
+            </a:r>
+          </a:p>
+          <a:p>
+            <a:pPr marL="0" indent="0">
+              <a:buNone/>
+            </a:pPr>
+            <a:r>
+              <a:rPr sz="1600">
+                <a:solidFill>
+                  <a:schemeClr val="bg1"/>
+                </a:solidFill>
+                <a:latin typeface="Consolas"/>
+              </a:rPr>
+              <a:t># ...add your feature, test it...</a:t>
+            </a:r>
+          </a:p>
+          <a:p>
+            <a:pPr marL="0" indent="0">
+              <a:buNone/>
+            </a:pPr>
+            <a:r>
+              <a:rPr sz="1600">
+                <a:solidFill>
+                  <a:schemeClr val="bg1"/>
+                </a:solidFill>
+                <a:latin typeface="Consolas"/>
+              </a:rPr>
+              <a:t>git add .                      # stage changes</a:t>
+            </a:r>
+          </a:p>
+          <a:p>
+            <a:pPr marL="0" indent="0">
+              <a:buNone/>
+            </a:pPr>
+            <a:r>
+              <a:rPr sz="1600">
+                <a:solidFill>
+                  <a:schemeClr val="bg1"/>
+                </a:solidFill>
+                <a:latin typeface="Consolas"/>
+              </a:rPr>
+              <a:t>git commit -m "Add &lt;feature&gt;"   # save a snapshot</a:t>
+            </a:r>
+          </a:p>
+          <a:p>
+            <a:pPr marL="0" indent="0">
+              <a:buNone/>
+            </a:pPr>
+            <a:r>
+              <a:rPr sz="1600">
+                <a:solidFill>
+                  <a:schemeClr val="bg1"/>
+                </a:solidFill>
+                <a:latin typeface="Consolas"/>
+              </a:rPr>
+              <a:t>git push                       # share with the team</a:t>
+            </a:r>
+          </a:p>
+          <a:p>
+            <a:pPr marL="0" indent="0">
+              <a:buNone/>
+            </a:pPr>
+            <a:endParaRPr sz="1600">
+              <a:solidFill>
+                <a:schemeClr val="bg1"/>
+              </a:solidFill>
+              <a:latin typeface="Consolas"/>
+            </a:endParaRPr>
+          </a:p>
+          <a:p>
+            <a:pPr marL="0" indent="0">
+              <a:buNone/>
+            </a:pPr>
+            <a:r>
+              <a:rPr sz="1600">
+                <a:solidFill>
+                  <a:schemeClr val="bg1"/>
+                </a:solidFill>
+                <a:latin typeface="Consolas"/>
+              </a:rPr>
+              <a:t># Clear messages: "Add enemy", "Add coins", "Add HUD"</a:t>
+            </a:r>
+          </a:p>
+          <a:p>
+            <a:pPr marL="0" indent="0">
+              <a:buNone/>
+            </a:pPr>
+            <a:r>
+              <a:rPr sz="1600">
+                <a:solidFill>
+                  <a:schemeClr val="bg1"/>
+                </a:solidFill>
+                <a:latin typeface="Consolas"/>
+              </a:rPr>
+              <a:t># so the history reads like the feature list.</a:t>
+            </a:r>
+          </a:p>
+        </p:txBody>
+      </p:sp>
+      <p:sp>
+        <p:nvSpPr>
+          <p:cNvPr id="4" name="TextBox 3">
+            <a:extLst>
+              <a:ext uri="{FF2B5EF4-FFF2-40B4-BE49-F238E27FC236}">
+                <a16:creationId xmlns:a16="http://schemas.microsoft.com/office/drawing/2014/main" id="{37AD84AD-7306-691D-96CC-9CF7184D183C}"/>
+              </a:ext>
+            </a:extLst>
+          </p:cNvPr>
+          <p:cNvSpPr txBox="1"/>
+          <p:nvPr/>
+        </p:nvSpPr>
+        <p:spPr>
+          <a:xfrm>
+            <a:off x="457199" y="6583362"/>
+            <a:ext cx="2500010" cy="369332"/>
+          </a:xfrm>
+          <a:prstGeom prst="rect">
+            <a:avLst/>
+          </a:prstGeom>
+          <a:noFill/>
+        </p:spPr>
+        <p:txBody>
+          <a:bodyPr wrap="square" lIns="91440" tIns="45720" rIns="91440" bIns="45720" rtlCol="0" anchor="t">
+            <a:spAutoFit/>
+          </a:bodyPr>
+          <a:lstStyle/>
+          <a:p>
+            <a:r>
+              <a:rPr lang="en-US">
+                <a:solidFill>
+                  <a:schemeClr val="bg1"/>
+                </a:solidFill>
                 <a:ea typeface="Calibri"/>
                 <a:cs typeface="Calibri"/>
               </a:rPr>
@@ -6739,7 +6900,7 @@
 </p:sld>
 </file>
 
-<file path=ppt/slides/slide11.xml><?xml version="1.0" encoding="utf-8"?>
+<file path=ppt/slides/slide12.xml><?xml version="1.0" encoding="utf-8"?>
 <p:sld xmlns:a="http://schemas.openxmlformats.org/drawingml/2006/main" xmlns:r="http://schemas.openxmlformats.org/officeDocument/2006/relationships" xmlns:p="http://schemas.openxmlformats.org/presentationml/2006/main">
   <p:cSld>
     <p:spTree>
@@ -7098,7 +7259,7 @@
 </p:sld>
 </file>
 
-<file path=ppt/slides/slide12.xml><?xml version="1.0" encoding="utf-8"?>
+<file path=ppt/slides/slide13.xml><?xml version="1.0" encoding="utf-8"?>
 <p:sld xmlns:a="http://schemas.openxmlformats.org/drawingml/2006/main" xmlns:r="http://schemas.openxmlformats.org/officeDocument/2006/relationships" xmlns:p="http://schemas.openxmlformats.org/presentationml/2006/main">
   <p:cSld>
     <p:spTree>
@@ -7484,7 +7645,7 @@
 </p:sld>
 </file>
 
-<file path=ppt/slides/slide13.xml><?xml version="1.0" encoding="utf-8"?>
+<file path=ppt/slides/slide14.xml><?xml version="1.0" encoding="utf-8"?>
 <p:sld xmlns:a="http://schemas.openxmlformats.org/drawingml/2006/main" xmlns:r="http://schemas.openxmlformats.org/officeDocument/2006/relationships" xmlns:p="http://schemas.openxmlformats.org/presentationml/2006/main">
   <p:cSld>
     <p:spTree>
@@ -7900,7 +8061,7 @@
 </p:sld>
 </file>
 
-<file path=ppt/slides/slide14.xml><?xml version="1.0" encoding="utf-8"?>
+<file path=ppt/slides/slide15.xml><?xml version="1.0" encoding="utf-8"?>
 <p:sld xmlns:a="http://schemas.openxmlformats.org/drawingml/2006/main" xmlns:r="http://schemas.openxmlformats.org/officeDocument/2006/relationships" xmlns:p="http://schemas.openxmlformats.org/presentationml/2006/main">
   <p:cSld>
     <p:spTree>
@@ -8325,7 +8486,7 @@
 </p:sld>
 </file>
 
-<file path=ppt/slides/slide15.xml><?xml version="1.0" encoding="utf-8"?>
+<file path=ppt/slides/slide16.xml><?xml version="1.0" encoding="utf-8"?>
 <p:sld xmlns:a="http://schemas.openxmlformats.org/drawingml/2006/main" xmlns:r="http://schemas.openxmlformats.org/officeDocument/2006/relationships" xmlns:p="http://schemas.openxmlformats.org/presentationml/2006/main">
   <p:cSld>
     <p:spTree>
@@ -8705,7 +8866,7 @@
 </p:sld>
 </file>
 
-<file path=ppt/slides/slide16.xml><?xml version="1.0" encoding="utf-8"?>
+<file path=ppt/slides/slide17.xml><?xml version="1.0" encoding="utf-8"?>
 <p:sld xmlns:a="http://schemas.openxmlformats.org/drawingml/2006/main" xmlns:r="http://schemas.openxmlformats.org/officeDocument/2006/relationships" xmlns:p="http://schemas.openxmlformats.org/presentationml/2006/main">
   <p:cSld>
     <p:spTree>
@@ -9085,7 +9246,7 @@
 </p:sld>
 </file>
 
-<file path=ppt/slides/slide17.xml><?xml version="1.0" encoding="utf-8"?>
+<file path=ppt/slides/slide18.xml><?xml version="1.0" encoding="utf-8"?>
 <p:sld xmlns:a="http://schemas.openxmlformats.org/drawingml/2006/main" xmlns:r="http://schemas.openxmlformats.org/officeDocument/2006/relationships" xmlns:p="http://schemas.openxmlformats.org/presentationml/2006/main">
   <p:cSld>
     <p:spTree>
@@ -9388,7 +9549,7 @@
 </p:sld>
 </file>
 
-<file path=ppt/slides/slide18.xml><?xml version="1.0" encoding="utf-8"?>
+<file path=ppt/slides/slide19.xml><?xml version="1.0" encoding="utf-8"?>
 <p:sld xmlns:a="http://schemas.openxmlformats.org/drawingml/2006/main" xmlns:r="http://schemas.openxmlformats.org/officeDocument/2006/relationships" xmlns:p="http://schemas.openxmlformats.org/presentationml/2006/main">
   <p:cSld>
     <p:spTree>
@@ -9651,7 +9812,346 @@
 </p:sld>
 </file>
 
-<file path=ppt/slides/slide19.xml><?xml version="1.0" encoding="utf-8"?>
+<file path=ppt/slides/slide2.xml><?xml version="1.0" encoding="utf-8"?>
+<p:sld xmlns:a="http://schemas.openxmlformats.org/drawingml/2006/main" xmlns:r="http://schemas.openxmlformats.org/officeDocument/2006/relationships" xmlns:p="http://schemas.openxmlformats.org/presentationml/2006/main">
+  <p:cSld>
+    <p:spTree>
+      <p:nvGrpSpPr>
+        <p:cNvPr id="1" name=""/>
+        <p:cNvGrpSpPr/>
+        <p:nvPr/>
+      </p:nvGrpSpPr>
+      <p:grpSpPr>
+        <a:xfrm>
+          <a:off x="0" y="0"/>
+          <a:ext cx="0" cy="0"/>
+          <a:chOff x="0" y="0"/>
+          <a:chExt cx="0" cy="0"/>
+        </a:xfrm>
+      </p:grpSpPr>
+      <p:sp>
+        <p:nvSpPr>
+          <p:cNvPr id="4" name="Title 3">
+            <a:extLst>
+              <a:ext uri="{FF2B5EF4-FFF2-40B4-BE49-F238E27FC236}">
+                <a16:creationId xmlns:a16="http://schemas.microsoft.com/office/drawing/2014/main" id="{0E724556-9F57-4831-AE33-80081BC13ECB}"/>
+              </a:ext>
+            </a:extLst>
+          </p:cNvPr>
+          <p:cNvSpPr>
+            <a:spLocks noGrp="1"/>
+          </p:cNvSpPr>
+          <p:nvPr>
+            <p:ph type="title"/>
+          </p:nvPr>
+        </p:nvSpPr>
+        <p:spPr/>
+        <p:txBody>
+          <a:bodyPr/>
+          <a:lstStyle/>
+          <a:p>
+            <a:r>
+              <a:rPr lang="en-US" dirty="0"/>
+              <a:t>Sit with your TL# group</a:t>
+            </a:r>
+          </a:p>
+        </p:txBody>
+      </p:sp>
+      <p:sp>
+        <p:nvSpPr>
+          <p:cNvPr id="5" name="Rectangle 4">
+            <a:extLst>
+              <a:ext uri="{FF2B5EF4-FFF2-40B4-BE49-F238E27FC236}">
+                <a16:creationId xmlns:a16="http://schemas.microsoft.com/office/drawing/2014/main" id="{99E574F9-0B72-487A-AC62-E93F72F729BB}"/>
+              </a:ext>
+            </a:extLst>
+          </p:cNvPr>
+          <p:cNvSpPr/>
+          <p:nvPr/>
+        </p:nvSpPr>
+        <p:spPr>
+          <a:xfrm>
+            <a:off x="1088684" y="2476504"/>
+            <a:ext cx="1778001" cy="1098551"/>
+          </a:xfrm>
+          <a:prstGeom prst="rect">
+            <a:avLst/>
+          </a:prstGeom>
+        </p:spPr>
+        <p:style>
+          <a:lnRef idx="2">
+            <a:schemeClr val="accent1">
+              <a:shade val="50000"/>
+            </a:schemeClr>
+          </a:lnRef>
+          <a:fillRef idx="1">
+            <a:schemeClr val="accent1"/>
+          </a:fillRef>
+          <a:effectRef idx="0">
+            <a:schemeClr val="accent1"/>
+          </a:effectRef>
+          <a:fontRef idx="minor">
+            <a:schemeClr val="lt1"/>
+          </a:fontRef>
+        </p:style>
+        <p:txBody>
+          <a:bodyPr rtlCol="0" anchor="ctr"/>
+          <a:lstStyle/>
+          <a:p>
+            <a:pPr algn="l" fontAlgn="base"/>
+            <a:r>
+              <a:rPr lang="en-US" sz="2400" dirty="0">
+                <a:latin typeface="inherit"/>
+              </a:rPr>
+              <a:t>TL3s </a:t>
+            </a:r>
+          </a:p>
+          <a:p>
+            <a:pPr algn="l" fontAlgn="base"/>
+            <a:r>
+              <a:rPr lang="en-US" sz="2400" dirty="0">
+                <a:latin typeface="inherit"/>
+              </a:rPr>
+              <a:t>+ KC (a TL5)</a:t>
+            </a:r>
+          </a:p>
+        </p:txBody>
+      </p:sp>
+      <p:sp>
+        <p:nvSpPr>
+          <p:cNvPr id="6" name="Rectangle 5">
+            <a:extLst>
+              <a:ext uri="{FF2B5EF4-FFF2-40B4-BE49-F238E27FC236}">
+                <a16:creationId xmlns:a16="http://schemas.microsoft.com/office/drawing/2014/main" id="{184AE95F-4160-4944-A719-0E99FC3EDDE7}"/>
+              </a:ext>
+            </a:extLst>
+          </p:cNvPr>
+          <p:cNvSpPr/>
+          <p:nvPr/>
+        </p:nvSpPr>
+        <p:spPr>
+          <a:xfrm>
+            <a:off x="3712012" y="4203898"/>
+            <a:ext cx="1955800" cy="1006139"/>
+          </a:xfrm>
+          <a:prstGeom prst="rect">
+            <a:avLst/>
+          </a:prstGeom>
+        </p:spPr>
+        <p:style>
+          <a:lnRef idx="2">
+            <a:schemeClr val="accent1">
+              <a:shade val="50000"/>
+            </a:schemeClr>
+          </a:lnRef>
+          <a:fillRef idx="1">
+            <a:schemeClr val="accent1"/>
+          </a:fillRef>
+          <a:effectRef idx="0">
+            <a:schemeClr val="accent1"/>
+          </a:effectRef>
+          <a:fontRef idx="minor">
+            <a:schemeClr val="lt1"/>
+          </a:fontRef>
+        </p:style>
+        <p:txBody>
+          <a:bodyPr rtlCol="0" anchor="ctr"/>
+          <a:lstStyle/>
+          <a:p>
+            <a:pPr algn="l" fontAlgn="base"/>
+            <a:r>
+              <a:rPr lang="en-US" sz="2400" dirty="0">
+                <a:latin typeface="inherit"/>
+              </a:rPr>
+              <a:t>The remaining TL5s and TL6s</a:t>
+            </a:r>
+          </a:p>
+        </p:txBody>
+      </p:sp>
+      <p:sp>
+        <p:nvSpPr>
+          <p:cNvPr id="7" name="Rectangle 6">
+            <a:extLst>
+              <a:ext uri="{FF2B5EF4-FFF2-40B4-BE49-F238E27FC236}">
+                <a16:creationId xmlns:a16="http://schemas.microsoft.com/office/drawing/2014/main" id="{D66B3CF8-354B-402F-BDD9-62005B47D0F6}"/>
+              </a:ext>
+            </a:extLst>
+          </p:cNvPr>
+          <p:cNvSpPr/>
+          <p:nvPr/>
+        </p:nvSpPr>
+        <p:spPr>
+          <a:xfrm>
+            <a:off x="6132140" y="2533653"/>
+            <a:ext cx="2159001" cy="1028699"/>
+          </a:xfrm>
+          <a:prstGeom prst="rect">
+            <a:avLst/>
+          </a:prstGeom>
+        </p:spPr>
+        <p:style>
+          <a:lnRef idx="2">
+            <a:schemeClr val="accent1">
+              <a:shade val="50000"/>
+            </a:schemeClr>
+          </a:lnRef>
+          <a:fillRef idx="1">
+            <a:schemeClr val="accent1"/>
+          </a:fillRef>
+          <a:effectRef idx="0">
+            <a:schemeClr val="accent1"/>
+          </a:effectRef>
+          <a:fontRef idx="minor">
+            <a:schemeClr val="lt1"/>
+          </a:fontRef>
+        </p:style>
+        <p:txBody>
+          <a:bodyPr rtlCol="0" anchor="ctr"/>
+          <a:lstStyle/>
+          <a:p>
+            <a:pPr algn="l" fontAlgn="base"/>
+            <a:r>
+              <a:rPr lang="en-US" sz="2400" dirty="0">
+                <a:latin typeface="inherit"/>
+              </a:rPr>
+              <a:t>TL4s </a:t>
+            </a:r>
+          </a:p>
+          <a:p>
+            <a:pPr algn="l" fontAlgn="base"/>
+            <a:r>
+              <a:rPr lang="en-US" sz="2400" dirty="0">
+                <a:latin typeface="inherit"/>
+              </a:rPr>
+              <a:t>+ </a:t>
+            </a:r>
+            <a:r>
+              <a:rPr lang="en-US" sz="2400" dirty="0" err="1">
+                <a:latin typeface="inherit"/>
+              </a:rPr>
+              <a:t>Rinab</a:t>
+            </a:r>
+            <a:r>
+              <a:rPr lang="en-US" sz="2400" dirty="0">
+                <a:latin typeface="inherit"/>
+              </a:rPr>
+              <a:t> ( a TL6)</a:t>
+            </a:r>
+          </a:p>
+        </p:txBody>
+      </p:sp>
+      <p:sp>
+        <p:nvSpPr>
+          <p:cNvPr id="8" name="Rectangle 7">
+            <a:extLst>
+              <a:ext uri="{FF2B5EF4-FFF2-40B4-BE49-F238E27FC236}">
+                <a16:creationId xmlns:a16="http://schemas.microsoft.com/office/drawing/2014/main" id="{48A9D0ED-0211-43F6-95FB-2C60A2047633}"/>
+              </a:ext>
+            </a:extLst>
+          </p:cNvPr>
+          <p:cNvSpPr/>
+          <p:nvPr/>
+        </p:nvSpPr>
+        <p:spPr>
+          <a:xfrm>
+            <a:off x="4232712" y="2968631"/>
+            <a:ext cx="914400" cy="819149"/>
+          </a:xfrm>
+          <a:prstGeom prst="rect">
+            <a:avLst/>
+          </a:prstGeom>
+        </p:spPr>
+        <p:style>
+          <a:lnRef idx="2">
+            <a:schemeClr val="accent1">
+              <a:shade val="50000"/>
+            </a:schemeClr>
+          </a:lnRef>
+          <a:fillRef idx="1">
+            <a:schemeClr val="accent1"/>
+          </a:fillRef>
+          <a:effectRef idx="0">
+            <a:schemeClr val="accent1"/>
+          </a:effectRef>
+          <a:fontRef idx="minor">
+            <a:schemeClr val="lt1"/>
+          </a:fontRef>
+        </p:style>
+        <p:txBody>
+          <a:bodyPr rtlCol="0" anchor="ctr"/>
+          <a:lstStyle/>
+          <a:p>
+            <a:pPr algn="l" fontAlgn="base"/>
+            <a:r>
+              <a:rPr lang="en-US" sz="2400" dirty="0">
+                <a:latin typeface="inherit"/>
+              </a:rPr>
+              <a:t>TL1s</a:t>
+            </a:r>
+          </a:p>
+        </p:txBody>
+      </p:sp>
+      <p:sp>
+        <p:nvSpPr>
+          <p:cNvPr id="2" name="Rectangle 1">
+            <a:extLst>
+              <a:ext uri="{FF2B5EF4-FFF2-40B4-BE49-F238E27FC236}">
+                <a16:creationId xmlns:a16="http://schemas.microsoft.com/office/drawing/2014/main" id="{604948A4-E99E-F5D9-8E5C-ED8B75518D00}"/>
+              </a:ext>
+            </a:extLst>
+          </p:cNvPr>
+          <p:cNvSpPr/>
+          <p:nvPr/>
+        </p:nvSpPr>
+        <p:spPr>
+          <a:xfrm>
+            <a:off x="-114953" y="1406241"/>
+            <a:ext cx="9258953" cy="438912"/>
+          </a:xfrm>
+          <a:prstGeom prst="rect">
+            <a:avLst/>
+          </a:prstGeom>
+        </p:spPr>
+        <p:style>
+          <a:lnRef idx="1">
+            <a:schemeClr val="accent1"/>
+          </a:lnRef>
+          <a:fillRef idx="3">
+            <a:schemeClr val="accent1"/>
+          </a:fillRef>
+          <a:effectRef idx="2">
+            <a:schemeClr val="accent1"/>
+          </a:effectRef>
+          <a:fontRef idx="minor">
+            <a:schemeClr val="lt1"/>
+          </a:fontRef>
+        </p:style>
+        <p:txBody>
+          <a:bodyPr rtlCol="0" anchor="ctr"/>
+          <a:lstStyle/>
+          <a:p>
+            <a:pPr algn="ctr"/>
+            <a:r>
+              <a:rPr lang="en-US" i="1" dirty="0"/>
+              <a:t>Front Of Room</a:t>
+            </a:r>
+          </a:p>
+        </p:txBody>
+      </p:sp>
+    </p:spTree>
+    <p:extLst>
+      <p:ext uri="{BB962C8B-B14F-4D97-AF65-F5344CB8AC3E}">
+        <p14:creationId xmlns:p14="http://schemas.microsoft.com/office/powerpoint/2010/main" val="1713719437"/>
+      </p:ext>
+    </p:extLst>
+  </p:cSld>
+  <p:clrMapOvr>
+    <a:masterClrMapping/>
+  </p:clrMapOvr>
+</p:sld>
+</file>
+
+<file path=ppt/slides/slide20.xml><?xml version="1.0" encoding="utf-8"?>
 <p:sld xmlns:a="http://schemas.openxmlformats.org/drawingml/2006/main" xmlns:r="http://schemas.openxmlformats.org/officeDocument/2006/relationships" xmlns:p="http://schemas.openxmlformats.org/presentationml/2006/main">
   <p:cSld>
     <p:spTree>
@@ -9803,7 +10303,442 @@
 </p:sld>
 </file>
 
-<file path=ppt/slides/slide2.xml><?xml version="1.0" encoding="utf-8"?>
+<file path=ppt/slides/slide21.xml><?xml version="1.0" encoding="utf-8"?>
+<p:sld xmlns:a="http://schemas.openxmlformats.org/drawingml/2006/main" xmlns:r="http://schemas.openxmlformats.org/officeDocument/2006/relationships" xmlns:p="http://schemas.openxmlformats.org/presentationml/2006/main">
+  <p:cSld>
+    <p:spTree>
+      <p:nvGrpSpPr>
+        <p:cNvPr id="1" name=""/>
+        <p:cNvGrpSpPr/>
+        <p:nvPr/>
+      </p:nvGrpSpPr>
+      <p:grpSpPr>
+        <a:xfrm>
+          <a:off x="0" y="0"/>
+          <a:ext cx="0" cy="0"/>
+          <a:chOff x="0" y="0"/>
+          <a:chExt cx="0" cy="0"/>
+        </a:xfrm>
+      </p:grpSpPr>
+      <p:sp>
+        <p:nvSpPr>
+          <p:cNvPr id="2" name="Title 1"/>
+          <p:cNvSpPr>
+            <a:spLocks noGrp="1"/>
+          </p:cNvSpPr>
+          <p:nvPr>
+            <p:ph type="title"/>
+          </p:nvPr>
+        </p:nvSpPr>
+        <p:spPr/>
+        <p:txBody>
+          <a:bodyPr/>
+          <a:lstStyle/>
+          <a:p>
+            <a:r>
+              <a:t>The Everyday Loop</a:t>
+            </a:r>
+          </a:p>
+        </p:txBody>
+      </p:sp>
+      <p:sp>
+        <p:nvSpPr>
+          <p:cNvPr id="3" name="Content Placeholder 2"/>
+          <p:cNvSpPr>
+            <a:spLocks noGrp="1"/>
+          </p:cNvSpPr>
+          <p:nvPr>
+            <p:ph idx="1"/>
+          </p:nvPr>
+        </p:nvSpPr>
+        <p:spPr/>
+        <p:txBody>
+          <a:bodyPr/>
+          <a:lstStyle/>
+          <a:p>
+            <a:r>
+              <a:t>The loop you repeat for every feature you add:</a:t>
+            </a:r>
+          </a:p>
+          <a:p>
+            <a:r>
+              <a:t>1 — </a:t>
+            </a:r>
+            <a:r>
+              <a:rPr u="sng"/>
+              <a:t>Pull</a:t>
+            </a:r>
+            <a:r>
+              <a:t> first, so you're on the latest team version.</a:t>
+            </a:r>
+          </a:p>
+          <a:p>
+            <a:r>
+              <a:t>2 — Build your feature and TEST it.</a:t>
+            </a:r>
+          </a:p>
+          <a:p>
+            <a:r>
+              <a:t>3 — Stage → commit (clear message) → push.</a:t>
+            </a:r>
+          </a:p>
+          <a:p>
+            <a:r>
+              <a:t>4 — If a teammate pushed while you worked: pull, resolve, push. (You just practiced this.)</a:t>
+            </a:r>
+          </a:p>
+        </p:txBody>
+      </p:sp>
+      <p:sp>
+        <p:nvSpPr>
+          <p:cNvPr id="4" name="TextBox 3">
+            <a:extLst>
+              <a:ext uri="{FF2B5EF4-FFF2-40B4-BE49-F238E27FC236}">
+                <a16:creationId xmlns:a16="http://schemas.microsoft.com/office/drawing/2014/main" id="{5E05CD6F-FB99-1A6D-5847-024A29218E6B}"/>
+              </a:ext>
+            </a:extLst>
+          </p:cNvPr>
+          <p:cNvSpPr txBox="1"/>
+          <p:nvPr/>
+        </p:nvSpPr>
+        <p:spPr>
+          <a:xfrm>
+            <a:off x="457199" y="6583362"/>
+            <a:ext cx="2500010" cy="646331"/>
+          </a:xfrm>
+          <a:prstGeom prst="rect">
+            <a:avLst/>
+          </a:prstGeom>
+          <a:noFill/>
+        </p:spPr>
+        <p:txBody>
+          <a:bodyPr wrap="square" rtlCol="0">
+            <a:spAutoFit/>
+          </a:bodyPr>
+          <a:lstStyle/>
+          <a:p>
+            <a:r>
+              <a:rPr lang="en-US">
+                <a:solidFill>
+                  <a:schemeClr val="bg1"/>
+                </a:solidFill>
+              </a:rPr>
+              <a:t>Breana Sinipete</a:t>
+            </a:r>
+          </a:p>
+          <a:p>
+            <a:endParaRPr lang="en-US">
+              <a:solidFill>
+                <a:schemeClr val="bg1"/>
+              </a:solidFill>
+            </a:endParaRPr>
+          </a:p>
+        </p:txBody>
+      </p:sp>
+    </p:spTree>
+  </p:cSld>
+  <p:clrMapOvr>
+    <a:masterClrMapping/>
+  </p:clrMapOvr>
+</p:sld>
+</file>
+
+<file path=ppt/slides/slide22.xml><?xml version="1.0" encoding="utf-8"?>
+<p:sld xmlns:a="http://schemas.openxmlformats.org/drawingml/2006/main" xmlns:r="http://schemas.openxmlformats.org/officeDocument/2006/relationships" xmlns:p="http://schemas.openxmlformats.org/presentationml/2006/main">
+  <p:cSld>
+    <p:spTree>
+      <p:nvGrpSpPr>
+        <p:cNvPr id="1" name=""/>
+        <p:cNvGrpSpPr/>
+        <p:nvPr/>
+      </p:nvGrpSpPr>
+      <p:grpSpPr>
+        <a:xfrm>
+          <a:off x="0" y="0"/>
+          <a:ext cx="0" cy="0"/>
+          <a:chOff x="0" y="0"/>
+          <a:chExt cx="0" cy="0"/>
+        </a:xfrm>
+      </p:grpSpPr>
+      <p:sp>
+        <p:nvSpPr>
+          <p:cNvPr id="2" name="Title 1"/>
+          <p:cNvSpPr>
+            <a:spLocks noGrp="1"/>
+          </p:cNvSpPr>
+          <p:nvPr>
+            <p:ph type="title"/>
+          </p:nvPr>
+        </p:nvSpPr>
+        <p:spPr/>
+        <p:txBody>
+          <a:bodyPr>
+            <a:normAutofit fontScale="90000"/>
+          </a:bodyPr>
+          <a:lstStyle/>
+          <a:p>
+            <a:r>
+              <a:t>What to Hand In — From Now On</a:t>
+            </a:r>
+          </a:p>
+        </p:txBody>
+      </p:sp>
+      <p:sp>
+        <p:nvSpPr>
+          <p:cNvPr id="3" name="Content Placeholder 2"/>
+          <p:cNvSpPr>
+            <a:spLocks noGrp="1"/>
+          </p:cNvSpPr>
+          <p:nvPr>
+            <p:ph idx="1"/>
+          </p:nvPr>
+        </p:nvSpPr>
+        <p:spPr/>
+        <p:txBody>
+          <a:bodyPr/>
+          <a:lstStyle/>
+          <a:p>
+            <a:r>
+              <a:t>From now on, all code you hand in is a LINK to a Git repository.</a:t>
+            </a:r>
+          </a:p>
+          <a:p>
+            <a:r>
+              <a:t>Not a zip, not a file upload — a repo link.</a:t>
+            </a:r>
+          </a:p>
+          <a:p>
+            <a:r>
+              <a:t>The commit history is part of the hand-in: it shows who did what, and when.</a:t>
+            </a:r>
+          </a:p>
+          <a:p>
+            <a:r>
+              <a:t>This is the same rule TL2 states — one rule, both lectures.</a:t>
+            </a:r>
+          </a:p>
+        </p:txBody>
+      </p:sp>
+      <p:sp>
+        <p:nvSpPr>
+          <p:cNvPr id="4" name="TextBox 3">
+            <a:extLst>
+              <a:ext uri="{FF2B5EF4-FFF2-40B4-BE49-F238E27FC236}">
+                <a16:creationId xmlns:a16="http://schemas.microsoft.com/office/drawing/2014/main" id="{374E5817-8551-E43A-81F8-3D1AFE7D21A0}"/>
+              </a:ext>
+            </a:extLst>
+          </p:cNvPr>
+          <p:cNvSpPr txBox="1"/>
+          <p:nvPr/>
+        </p:nvSpPr>
+        <p:spPr>
+          <a:xfrm>
+            <a:off x="457199" y="6583362"/>
+            <a:ext cx="2500010" cy="369332"/>
+          </a:xfrm>
+          <a:prstGeom prst="rect">
+            <a:avLst/>
+          </a:prstGeom>
+          <a:noFill/>
+        </p:spPr>
+        <p:txBody>
+          <a:bodyPr wrap="square" rtlCol="0">
+            <a:spAutoFit/>
+          </a:bodyPr>
+          <a:lstStyle/>
+          <a:p>
+            <a:r>
+              <a:rPr lang="en-US">
+                <a:solidFill>
+                  <a:schemeClr val="bg1"/>
+                </a:solidFill>
+              </a:rPr>
+              <a:t>Breana Sinipete</a:t>
+            </a:r>
+          </a:p>
+        </p:txBody>
+      </p:sp>
+    </p:spTree>
+  </p:cSld>
+  <p:clrMapOvr>
+    <a:masterClrMapping/>
+  </p:clrMapOvr>
+</p:sld>
+</file>
+
+<file path=ppt/slides/slide23.xml><?xml version="1.0" encoding="utf-8"?>
+<p:sld xmlns:a="http://schemas.openxmlformats.org/drawingml/2006/main" xmlns:r="http://schemas.openxmlformats.org/officeDocument/2006/relationships" xmlns:p="http://schemas.openxmlformats.org/presentationml/2006/main">
+  <p:cSld>
+    <p:spTree>
+      <p:nvGrpSpPr>
+        <p:cNvPr id="1" name=""/>
+        <p:cNvGrpSpPr/>
+        <p:nvPr/>
+      </p:nvGrpSpPr>
+      <p:grpSpPr>
+        <a:xfrm>
+          <a:off x="0" y="0"/>
+          <a:ext cx="0" cy="0"/>
+          <a:chOff x="0" y="0"/>
+          <a:chExt cx="0" cy="0"/>
+        </a:xfrm>
+      </p:grpSpPr>
+      <p:sp>
+        <p:nvSpPr>
+          <p:cNvPr id="2" name="Title 1"/>
+          <p:cNvSpPr>
+            <a:spLocks noGrp="1"/>
+          </p:cNvSpPr>
+          <p:nvPr>
+            <p:ph type="title"/>
+          </p:nvPr>
+        </p:nvSpPr>
+        <p:spPr>
+          <a:xfrm>
+            <a:off x="457200" y="274638"/>
+            <a:ext cx="7615645" cy="1143000"/>
+          </a:xfrm>
+        </p:spPr>
+        <p:txBody>
+          <a:bodyPr>
+            <a:normAutofit fontScale="90000"/>
+          </a:bodyPr>
+          <a:lstStyle/>
+          <a:p>
+            <a:r>
+              <a:t>How This Runs During TL2 Lecture 2</a:t>
+            </a:r>
+          </a:p>
+        </p:txBody>
+      </p:sp>
+      <p:sp>
+        <p:nvSpPr>
+          <p:cNvPr id="3" name="Content Placeholder 2"/>
+          <p:cNvSpPr>
+            <a:spLocks noGrp="1"/>
+          </p:cNvSpPr>
+          <p:nvPr>
+            <p:ph idx="1"/>
+          </p:nvPr>
+        </p:nvSpPr>
+        <p:spPr/>
+        <p:txBody>
+          <a:bodyPr>
+            <a:normAutofit fontScale="85000" lnSpcReduction="10000"/>
+          </a:bodyPr>
+          <a:lstStyle/>
+          <a:p>
+            <a:r>
+              <a:t>TL2 walks everyone through building each feature: enemies, coins, power-ups, animation, HUD, sound.</a:t>
+            </a:r>
+          </a:p>
+          <a:p>
+            <a:r>
+              <a:t>At each feature: the chosen version's author PUSHES; everyone else PULLS. Make sure every person gets at least one push.</a:t>
+            </a:r>
+          </a:p>
+          <a:p>
+            <a:r>
+              <a:t>If a team struggles to push, a circulating TL1 helps</a:t>
+            </a:r>
+            <a:r>
+              <a:rPr lang="en-US"/>
+              <a:t>, </a:t>
+            </a:r>
+            <a:r>
+              <a:t>and earns a support credit (</a:t>
+            </a:r>
+            <a:r>
+              <a:rPr>
+                <a:solidFill>
+                  <a:srgbClr val="FF0000"/>
+                </a:solidFill>
+              </a:rPr>
+              <a:t>LEC</a:t>
+            </a:r>
+            <a:r>
+              <a:t>) for it.</a:t>
+            </a:r>
+            <a:r>
+              <a:rPr lang="en-US"/>
+              <a:t> Don’t forget to do a </a:t>
+            </a:r>
+            <a:r>
+              <a:rPr lang="en-US">
+                <a:solidFill>
+                  <a:srgbClr val="FF0000"/>
+                </a:solidFill>
+              </a:rPr>
+              <a:t>REC-LEC</a:t>
+            </a:r>
+            <a:r>
+              <a:rPr lang="en-US"/>
+              <a:t>.</a:t>
+            </a:r>
+            <a:endParaRPr/>
+          </a:p>
+          <a:p>
+            <a:r>
+              <a:t>By the end: the platformer is a merge of everyone's work, with a clean history showing who did what.</a:t>
+            </a:r>
+          </a:p>
+        </p:txBody>
+      </p:sp>
+      <p:sp>
+        <p:nvSpPr>
+          <p:cNvPr id="4" name="TextBox 3">
+            <a:extLst>
+              <a:ext uri="{FF2B5EF4-FFF2-40B4-BE49-F238E27FC236}">
+                <a16:creationId xmlns:a16="http://schemas.microsoft.com/office/drawing/2014/main" id="{BA49BD22-11DE-4556-E9E4-720C59FC692D}"/>
+              </a:ext>
+            </a:extLst>
+          </p:cNvPr>
+          <p:cNvSpPr txBox="1"/>
+          <p:nvPr/>
+        </p:nvSpPr>
+        <p:spPr>
+          <a:xfrm>
+            <a:off x="457199" y="6583362"/>
+            <a:ext cx="2500010" cy="646331"/>
+          </a:xfrm>
+          <a:prstGeom prst="rect">
+            <a:avLst/>
+          </a:prstGeom>
+          <a:noFill/>
+        </p:spPr>
+        <p:txBody>
+          <a:bodyPr wrap="square" rtlCol="0">
+            <a:spAutoFit/>
+          </a:bodyPr>
+          <a:lstStyle/>
+          <a:p>
+            <a:r>
+              <a:rPr lang="en-US">
+                <a:solidFill>
+                  <a:schemeClr val="bg1"/>
+                </a:solidFill>
+              </a:rPr>
+              <a:t>Breana Sinipete</a:t>
+            </a:r>
+          </a:p>
+          <a:p>
+            <a:endParaRPr lang="en-US">
+              <a:solidFill>
+                <a:schemeClr val="bg1"/>
+              </a:solidFill>
+            </a:endParaRPr>
+          </a:p>
+        </p:txBody>
+      </p:sp>
+    </p:spTree>
+  </p:cSld>
+  <p:clrMapOvr>
+    <a:masterClrMapping/>
+  </p:clrMapOvr>
+</p:sld>
+</file>
+
+<file path=ppt/slides/slide3.xml><?xml version="1.0" encoding="utf-8"?>
 <p:sld xmlns:a="http://schemas.openxmlformats.org/drawingml/2006/main" xmlns:r="http://schemas.openxmlformats.org/officeDocument/2006/relationships" xmlns:p="http://schemas.openxmlformats.org/presentationml/2006/main">
   <p:cSld>
     <p:spTree>
@@ -10014,566 +10949,6 @@
 </p:sld>
 </file>
 
-<file path=ppt/slides/slide20.xml><?xml version="1.0" encoding="utf-8"?>
-<p:sld xmlns:a="http://schemas.openxmlformats.org/drawingml/2006/main" xmlns:r="http://schemas.openxmlformats.org/officeDocument/2006/relationships" xmlns:p="http://schemas.openxmlformats.org/presentationml/2006/main">
-  <p:cSld>
-    <p:spTree>
-      <p:nvGrpSpPr>
-        <p:cNvPr id="1" name=""/>
-        <p:cNvGrpSpPr/>
-        <p:nvPr/>
-      </p:nvGrpSpPr>
-      <p:grpSpPr>
-        <a:xfrm>
-          <a:off x="0" y="0"/>
-          <a:ext cx="0" cy="0"/>
-          <a:chOff x="0" y="0"/>
-          <a:chExt cx="0" cy="0"/>
-        </a:xfrm>
-      </p:grpSpPr>
-      <p:sp>
-        <p:nvSpPr>
-          <p:cNvPr id="2" name="Title 1"/>
-          <p:cNvSpPr>
-            <a:spLocks noGrp="1"/>
-          </p:cNvSpPr>
-          <p:nvPr>
-            <p:ph type="title"/>
-          </p:nvPr>
-        </p:nvSpPr>
-        <p:spPr/>
-        <p:txBody>
-          <a:bodyPr/>
-          <a:lstStyle/>
-          <a:p>
-            <a:r>
-              <a:t>The Everyday Loop</a:t>
-            </a:r>
-          </a:p>
-        </p:txBody>
-      </p:sp>
-      <p:sp>
-        <p:nvSpPr>
-          <p:cNvPr id="3" name="Content Placeholder 2"/>
-          <p:cNvSpPr>
-            <a:spLocks noGrp="1"/>
-          </p:cNvSpPr>
-          <p:nvPr>
-            <p:ph idx="1"/>
-          </p:nvPr>
-        </p:nvSpPr>
-        <p:spPr/>
-        <p:txBody>
-          <a:bodyPr/>
-          <a:lstStyle/>
-          <a:p>
-            <a:r>
-              <a:t>The loop you repeat for every feature you add:</a:t>
-            </a:r>
-          </a:p>
-          <a:p>
-            <a:r>
-              <a:t>1 — </a:t>
-            </a:r>
-            <a:r>
-              <a:rPr u="sng"/>
-              <a:t>Pull</a:t>
-            </a:r>
-            <a:r>
-              <a:t> first, so you're on the latest team version.</a:t>
-            </a:r>
-          </a:p>
-          <a:p>
-            <a:r>
-              <a:t>2 — Build your feature and TEST it.</a:t>
-            </a:r>
-          </a:p>
-          <a:p>
-            <a:r>
-              <a:t>3 — Stage → commit (clear message) → push.</a:t>
-            </a:r>
-          </a:p>
-          <a:p>
-            <a:r>
-              <a:t>4 — If a teammate pushed while you worked: pull, resolve, push. (You just practiced this.)</a:t>
-            </a:r>
-          </a:p>
-        </p:txBody>
-      </p:sp>
-      <p:sp>
-        <p:nvSpPr>
-          <p:cNvPr id="4" name="TextBox 3">
-            <a:extLst>
-              <a:ext uri="{FF2B5EF4-FFF2-40B4-BE49-F238E27FC236}">
-                <a16:creationId xmlns:a16="http://schemas.microsoft.com/office/drawing/2014/main" id="{5E05CD6F-FB99-1A6D-5847-024A29218E6B}"/>
-              </a:ext>
-            </a:extLst>
-          </p:cNvPr>
-          <p:cNvSpPr txBox="1"/>
-          <p:nvPr/>
-        </p:nvSpPr>
-        <p:spPr>
-          <a:xfrm>
-            <a:off x="457199" y="6583362"/>
-            <a:ext cx="2500010" cy="646331"/>
-          </a:xfrm>
-          <a:prstGeom prst="rect">
-            <a:avLst/>
-          </a:prstGeom>
-          <a:noFill/>
-        </p:spPr>
-        <p:txBody>
-          <a:bodyPr wrap="square" rtlCol="0">
-            <a:spAutoFit/>
-          </a:bodyPr>
-          <a:lstStyle/>
-          <a:p>
-            <a:r>
-              <a:rPr lang="en-US">
-                <a:solidFill>
-                  <a:schemeClr val="bg1"/>
-                </a:solidFill>
-              </a:rPr>
-              <a:t>Breana Sinipete</a:t>
-            </a:r>
-          </a:p>
-          <a:p>
-            <a:endParaRPr lang="en-US">
-              <a:solidFill>
-                <a:schemeClr val="bg1"/>
-              </a:solidFill>
-            </a:endParaRPr>
-          </a:p>
-        </p:txBody>
-      </p:sp>
-    </p:spTree>
-  </p:cSld>
-  <p:clrMapOvr>
-    <a:masterClrMapping/>
-  </p:clrMapOvr>
-</p:sld>
-</file>
-
-<file path=ppt/slides/slide21.xml><?xml version="1.0" encoding="utf-8"?>
-<p:sld xmlns:a="http://schemas.openxmlformats.org/drawingml/2006/main" xmlns:r="http://schemas.openxmlformats.org/officeDocument/2006/relationships" xmlns:p="http://schemas.openxmlformats.org/presentationml/2006/main">
-  <p:cSld>
-    <p:spTree>
-      <p:nvGrpSpPr>
-        <p:cNvPr id="1" name=""/>
-        <p:cNvGrpSpPr/>
-        <p:nvPr/>
-      </p:nvGrpSpPr>
-      <p:grpSpPr>
-        <a:xfrm>
-          <a:off x="0" y="0"/>
-          <a:ext cx="0" cy="0"/>
-          <a:chOff x="0" y="0"/>
-          <a:chExt cx="0" cy="0"/>
-        </a:xfrm>
-      </p:grpSpPr>
-      <p:sp>
-        <p:nvSpPr>
-          <p:cNvPr id="2" name="Title 1"/>
-          <p:cNvSpPr>
-            <a:spLocks noGrp="1"/>
-          </p:cNvSpPr>
-          <p:nvPr>
-            <p:ph type="title"/>
-          </p:nvPr>
-        </p:nvSpPr>
-        <p:spPr/>
-        <p:txBody>
-          <a:bodyPr>
-            <a:normAutofit fontScale="90000"/>
-          </a:bodyPr>
-          <a:lstStyle/>
-          <a:p>
-            <a:r>
-              <a:t>What to Hand In — From Now On</a:t>
-            </a:r>
-          </a:p>
-        </p:txBody>
-      </p:sp>
-      <p:sp>
-        <p:nvSpPr>
-          <p:cNvPr id="3" name="Content Placeholder 2"/>
-          <p:cNvSpPr>
-            <a:spLocks noGrp="1"/>
-          </p:cNvSpPr>
-          <p:nvPr>
-            <p:ph idx="1"/>
-          </p:nvPr>
-        </p:nvSpPr>
-        <p:spPr/>
-        <p:txBody>
-          <a:bodyPr/>
-          <a:lstStyle/>
-          <a:p>
-            <a:r>
-              <a:t>From now on, all code you hand in is a LINK to a Git repository.</a:t>
-            </a:r>
-          </a:p>
-          <a:p>
-            <a:r>
-              <a:t>Not a zip, not a file upload — a repo link.</a:t>
-            </a:r>
-          </a:p>
-          <a:p>
-            <a:r>
-              <a:t>The commit history is part of the hand-in: it shows who did what, and when.</a:t>
-            </a:r>
-          </a:p>
-          <a:p>
-            <a:r>
-              <a:t>This is the same rule TL2 states — one rule, both lectures.</a:t>
-            </a:r>
-          </a:p>
-        </p:txBody>
-      </p:sp>
-      <p:sp>
-        <p:nvSpPr>
-          <p:cNvPr id="4" name="TextBox 3">
-            <a:extLst>
-              <a:ext uri="{FF2B5EF4-FFF2-40B4-BE49-F238E27FC236}">
-                <a16:creationId xmlns:a16="http://schemas.microsoft.com/office/drawing/2014/main" id="{374E5817-8551-E43A-81F8-3D1AFE7D21A0}"/>
-              </a:ext>
-            </a:extLst>
-          </p:cNvPr>
-          <p:cNvSpPr txBox="1"/>
-          <p:nvPr/>
-        </p:nvSpPr>
-        <p:spPr>
-          <a:xfrm>
-            <a:off x="457199" y="6583362"/>
-            <a:ext cx="2500010" cy="369332"/>
-          </a:xfrm>
-          <a:prstGeom prst="rect">
-            <a:avLst/>
-          </a:prstGeom>
-          <a:noFill/>
-        </p:spPr>
-        <p:txBody>
-          <a:bodyPr wrap="square" rtlCol="0">
-            <a:spAutoFit/>
-          </a:bodyPr>
-          <a:lstStyle/>
-          <a:p>
-            <a:r>
-              <a:rPr lang="en-US">
-                <a:solidFill>
-                  <a:schemeClr val="bg1"/>
-                </a:solidFill>
-              </a:rPr>
-              <a:t>Breana Sinipete</a:t>
-            </a:r>
-          </a:p>
-        </p:txBody>
-      </p:sp>
-    </p:spTree>
-  </p:cSld>
-  <p:clrMapOvr>
-    <a:masterClrMapping/>
-  </p:clrMapOvr>
-</p:sld>
-</file>
-
-<file path=ppt/slides/slide22.xml><?xml version="1.0" encoding="utf-8"?>
-<p:sld xmlns:a="http://schemas.openxmlformats.org/drawingml/2006/main" xmlns:r="http://schemas.openxmlformats.org/officeDocument/2006/relationships" xmlns:p="http://schemas.openxmlformats.org/presentationml/2006/main">
-  <p:cSld>
-    <p:spTree>
-      <p:nvGrpSpPr>
-        <p:cNvPr id="1" name=""/>
-        <p:cNvGrpSpPr/>
-        <p:nvPr/>
-      </p:nvGrpSpPr>
-      <p:grpSpPr>
-        <a:xfrm>
-          <a:off x="0" y="0"/>
-          <a:ext cx="0" cy="0"/>
-          <a:chOff x="0" y="0"/>
-          <a:chExt cx="0" cy="0"/>
-        </a:xfrm>
-      </p:grpSpPr>
-      <p:sp>
-        <p:nvSpPr>
-          <p:cNvPr id="2" name="Title 1"/>
-          <p:cNvSpPr>
-            <a:spLocks noGrp="1"/>
-          </p:cNvSpPr>
-          <p:nvPr>
-            <p:ph type="title"/>
-          </p:nvPr>
-        </p:nvSpPr>
-        <p:spPr>
-          <a:xfrm>
-            <a:off x="457200" y="274638"/>
-            <a:ext cx="7615645" cy="1143000"/>
-          </a:xfrm>
-        </p:spPr>
-        <p:txBody>
-          <a:bodyPr>
-            <a:normAutofit fontScale="90000"/>
-          </a:bodyPr>
-          <a:lstStyle/>
-          <a:p>
-            <a:r>
-              <a:t>How This Runs During TL2 Lecture 2</a:t>
-            </a:r>
-          </a:p>
-        </p:txBody>
-      </p:sp>
-      <p:sp>
-        <p:nvSpPr>
-          <p:cNvPr id="3" name="Content Placeholder 2"/>
-          <p:cNvSpPr>
-            <a:spLocks noGrp="1"/>
-          </p:cNvSpPr>
-          <p:nvPr>
-            <p:ph idx="1"/>
-          </p:nvPr>
-        </p:nvSpPr>
-        <p:spPr/>
-        <p:txBody>
-          <a:bodyPr>
-            <a:normAutofit fontScale="85000" lnSpcReduction="10000"/>
-          </a:bodyPr>
-          <a:lstStyle/>
-          <a:p>
-            <a:r>
-              <a:t>TL2 walks everyone through building each feature: enemies, coins, power-ups, animation, HUD, sound.</a:t>
-            </a:r>
-          </a:p>
-          <a:p>
-            <a:r>
-              <a:t>At each feature: the chosen version's author PUSHES; everyone else PULLS. Make sure every person gets at least one push.</a:t>
-            </a:r>
-          </a:p>
-          <a:p>
-            <a:r>
-              <a:t>If a team struggles to push, a circulating TL1 helps</a:t>
-            </a:r>
-            <a:r>
-              <a:rPr lang="en-US"/>
-              <a:t>, </a:t>
-            </a:r>
-            <a:r>
-              <a:t>and earns a support credit (</a:t>
-            </a:r>
-            <a:r>
-              <a:rPr>
-                <a:solidFill>
-                  <a:srgbClr val="FF0000"/>
-                </a:solidFill>
-              </a:rPr>
-              <a:t>LEC</a:t>
-            </a:r>
-            <a:r>
-              <a:t>) for it.</a:t>
-            </a:r>
-            <a:r>
-              <a:rPr lang="en-US"/>
-              <a:t> Don’t forget to do a </a:t>
-            </a:r>
-            <a:r>
-              <a:rPr lang="en-US">
-                <a:solidFill>
-                  <a:srgbClr val="FF0000"/>
-                </a:solidFill>
-              </a:rPr>
-              <a:t>REC-LEC</a:t>
-            </a:r>
-            <a:r>
-              <a:rPr lang="en-US"/>
-              <a:t>.</a:t>
-            </a:r>
-            <a:endParaRPr/>
-          </a:p>
-          <a:p>
-            <a:r>
-              <a:t>By the end: the platformer is a merge of everyone's work, with a clean history showing who did what.</a:t>
-            </a:r>
-          </a:p>
-        </p:txBody>
-      </p:sp>
-      <p:sp>
-        <p:nvSpPr>
-          <p:cNvPr id="4" name="TextBox 3">
-            <a:extLst>
-              <a:ext uri="{FF2B5EF4-FFF2-40B4-BE49-F238E27FC236}">
-                <a16:creationId xmlns:a16="http://schemas.microsoft.com/office/drawing/2014/main" id="{BA49BD22-11DE-4556-E9E4-720C59FC692D}"/>
-              </a:ext>
-            </a:extLst>
-          </p:cNvPr>
-          <p:cNvSpPr txBox="1"/>
-          <p:nvPr/>
-        </p:nvSpPr>
-        <p:spPr>
-          <a:xfrm>
-            <a:off x="457199" y="6583362"/>
-            <a:ext cx="2500010" cy="646331"/>
-          </a:xfrm>
-          <a:prstGeom prst="rect">
-            <a:avLst/>
-          </a:prstGeom>
-          <a:noFill/>
-        </p:spPr>
-        <p:txBody>
-          <a:bodyPr wrap="square" rtlCol="0">
-            <a:spAutoFit/>
-          </a:bodyPr>
-          <a:lstStyle/>
-          <a:p>
-            <a:r>
-              <a:rPr lang="en-US">
-                <a:solidFill>
-                  <a:schemeClr val="bg1"/>
-                </a:solidFill>
-              </a:rPr>
-              <a:t>Breana Sinipete</a:t>
-            </a:r>
-          </a:p>
-          <a:p>
-            <a:endParaRPr lang="en-US">
-              <a:solidFill>
-                <a:schemeClr val="bg1"/>
-              </a:solidFill>
-            </a:endParaRPr>
-          </a:p>
-        </p:txBody>
-      </p:sp>
-    </p:spTree>
-  </p:cSld>
-  <p:clrMapOvr>
-    <a:masterClrMapping/>
-  </p:clrMapOvr>
-</p:sld>
-</file>
-
-<file path=ppt/slides/slide3.xml><?xml version="1.0" encoding="utf-8"?>
-<p:sld xmlns:a="http://schemas.openxmlformats.org/drawingml/2006/main" xmlns:r="http://schemas.openxmlformats.org/officeDocument/2006/relationships" xmlns:p="http://schemas.openxmlformats.org/presentationml/2006/main">
-  <p:cSld>
-    <p:spTree>
-      <p:nvGrpSpPr>
-        <p:cNvPr id="1" name=""/>
-        <p:cNvGrpSpPr/>
-        <p:nvPr/>
-      </p:nvGrpSpPr>
-      <p:grpSpPr>
-        <a:xfrm>
-          <a:off x="0" y="0"/>
-          <a:ext cx="0" cy="0"/>
-          <a:chOff x="0" y="0"/>
-          <a:chExt cx="0" cy="0"/>
-        </a:xfrm>
-      </p:grpSpPr>
-      <p:sp>
-        <p:nvSpPr>
-          <p:cNvPr id="2" name="Title 1"/>
-          <p:cNvSpPr>
-            <a:spLocks noGrp="1"/>
-          </p:cNvSpPr>
-          <p:nvPr>
-            <p:ph type="title"/>
-          </p:nvPr>
-        </p:nvSpPr>
-        <p:spPr/>
-        <p:txBody>
-          <a:bodyPr/>
-          <a:lstStyle/>
-          <a:p>
-            <a:r>
-              <a:t>Meet Your TL1 Team</a:t>
-            </a:r>
-          </a:p>
-        </p:txBody>
-      </p:sp>
-      <p:sp>
-        <p:nvSpPr>
-          <p:cNvPr id="3" name="Content Placeholder 2"/>
-          <p:cNvSpPr>
-            <a:spLocks noGrp="1"/>
-          </p:cNvSpPr>
-          <p:nvPr>
-            <p:ph idx="1"/>
-          </p:nvPr>
-        </p:nvSpPr>
-        <p:spPr/>
-        <p:txBody>
-          <a:bodyPr>
-            <a:normAutofit lnSpcReduction="10000"/>
-          </a:bodyPr>
-          <a:lstStyle/>
-          <a:p>
-            <a:r>
-              <a:t>We are your TL1 group — everyone across the class who shares TL number 1.</a:t>
-            </a:r>
-          </a:p>
-          <a:p>
-            <a:r>
-              <a:t>Each of us will introduce ourselves by name.</a:t>
-            </a:r>
-          </a:p>
-          <a:p>
-            <a:r>
-              <a:t>While one of us presents, the rest are circulating to help you set up Git.</a:t>
-            </a:r>
-          </a:p>
-          <a:p>
-            <a:r>
-              <a:t>Special: during the TL2 lecture, a TL1 can earn a support credit (LEC) for helping ANY team with a Git push / pull / merge problem — so flag us down all semester.</a:t>
-            </a:r>
-          </a:p>
-        </p:txBody>
-      </p:sp>
-      <p:sp>
-        <p:nvSpPr>
-          <p:cNvPr id="4" name="TextBox 3">
-            <a:extLst>
-              <a:ext uri="{FF2B5EF4-FFF2-40B4-BE49-F238E27FC236}">
-                <a16:creationId xmlns:a16="http://schemas.microsoft.com/office/drawing/2014/main" id="{7D55F5FB-BDF0-3964-45FF-8EB77DFF26B7}"/>
-              </a:ext>
-            </a:extLst>
-          </p:cNvPr>
-          <p:cNvSpPr txBox="1"/>
-          <p:nvPr/>
-        </p:nvSpPr>
-        <p:spPr>
-          <a:xfrm>
-            <a:off x="457200" y="6673334"/>
-            <a:ext cx="2500010" cy="369332"/>
-          </a:xfrm>
-          <a:prstGeom prst="rect">
-            <a:avLst/>
-          </a:prstGeom>
-          <a:noFill/>
-        </p:spPr>
-        <p:txBody>
-          <a:bodyPr wrap="square" lIns="91440" tIns="45720" rIns="91440" bIns="45720" rtlCol="0" anchor="t">
-            <a:spAutoFit/>
-          </a:bodyPr>
-          <a:lstStyle/>
-          <a:p>
-            <a:r>
-              <a:rPr lang="en-US" dirty="0">
-                <a:solidFill>
-                  <a:schemeClr val="bg1"/>
-                </a:solidFill>
-                <a:ea typeface="Calibri"/>
-                <a:cs typeface="Calibri"/>
-              </a:rPr>
-              <a:t>Adam</a:t>
-            </a:r>
-          </a:p>
-        </p:txBody>
-      </p:sp>
-    </p:spTree>
-  </p:cSld>
-  <p:clrMapOvr>
-    <a:masterClrMapping/>
-  </p:clrMapOvr>
-</p:sld>
-</file>
-
 <file path=ppt/slides/slide4.xml><?xml version="1.0" encoding="utf-8"?>
 <p:sld xmlns:a="http://schemas.openxmlformats.org/drawingml/2006/main" xmlns:r="http://schemas.openxmlformats.org/officeDocument/2006/relationships" xmlns:p="http://schemas.openxmlformats.org/presentationml/2006/main">
   <p:cSld>
@@ -10607,7 +10982,7 @@
           <a:lstStyle/>
           <a:p>
             <a:r>
-              <a:t>What We'll Do Today</a:t>
+              <a:t>Meet Your TL1 Team</a:t>
             </a:r>
           </a:p>
         </p:txBody>
@@ -10625,44 +11000,27 @@
         <p:spPr/>
         <p:txBody>
           <a:bodyPr>
-            <a:normAutofit fontScale="92500" lnSpcReduction="20000"/>
+            <a:normAutofit lnSpcReduction="10000"/>
           </a:bodyPr>
           <a:lstStyle/>
           <a:p>
             <a:r>
-              <a:t>1  Why the team needs one shared repository</a:t>
-            </a:r>
-          </a:p>
-          <a:p>
-            <a:r>
-              <a:t>2  Two repos, two very different jobs</a:t>
-            </a:r>
-          </a:p>
-          <a:p>
-            <a:r>
-              <a:t>3  Follow Along 1: create the platformer repo (+ .</a:t>
-            </a:r>
-            <a:r>
-              <a:rPr err="1"/>
-              <a:t>gitignore</a:t>
-            </a:r>
-            <a:r>
-              <a:t>) and load the base game</a:t>
-            </a:r>
-          </a:p>
-          <a:p>
-            <a:r>
-              <a:t>4  Follow Along 2: cause and resolve merge conflicts (TEAM.md)</a:t>
-            </a:r>
-          </a:p>
-          <a:p>
-            <a:r>
-              <a:t>5  Follow Along 3: prove you can reach the locked project repo</a:t>
-            </a:r>
-          </a:p>
-          <a:p>
-            <a:r>
-              <a:t>6  The everyday loop, what to hand in, and how this runs during TL2</a:t>
+              <a:t>We are your TL1 group — everyone across the class who shares TL number 1.</a:t>
+            </a:r>
+          </a:p>
+          <a:p>
+            <a:r>
+              <a:t>Each of us will introduce ourselves by name.</a:t>
+            </a:r>
+          </a:p>
+          <a:p>
+            <a:r>
+              <a:t>While one of us presents, the rest are circulating to help you set up Git.</a:t>
+            </a:r>
+          </a:p>
+          <a:p>
+            <a:r>
+              <a:t>Special: during the TL2 lecture, a TL1 can earn a support credit (LEC) for helping ANY team with a Git push / pull / merge problem — so flag us down all semester.</a:t>
             </a:r>
           </a:p>
         </p:txBody>
@@ -10672,7 +11030,7 @@
           <p:cNvPr id="4" name="TextBox 3">
             <a:extLst>
               <a:ext uri="{FF2B5EF4-FFF2-40B4-BE49-F238E27FC236}">
-                <a16:creationId xmlns:a16="http://schemas.microsoft.com/office/drawing/2014/main" id="{68D76FC4-A387-12B2-A548-3E07A9D18A62}"/>
+                <a16:creationId xmlns:a16="http://schemas.microsoft.com/office/drawing/2014/main" id="{7D55F5FB-BDF0-3964-45FF-8EB77DFF26B7}"/>
               </a:ext>
             </a:extLst>
           </p:cNvPr>
@@ -10681,7 +11039,7 @@
         </p:nvSpPr>
         <p:spPr>
           <a:xfrm>
-            <a:off x="457199" y="6583362"/>
+            <a:off x="457200" y="6673334"/>
             <a:ext cx="2500010" cy="369332"/>
           </a:xfrm>
           <a:prstGeom prst="rect">
@@ -10696,20 +11054,15 @@
           <a:lstStyle/>
           <a:p>
             <a:r>
-              <a:rPr lang="en-US">
-                <a:solidFill>
-                  <a:schemeClr val="bg1"/>
-                </a:solidFill>
+              <a:rPr lang="en-US" dirty="0">
+                <a:solidFill>
+                  <a:schemeClr val="bg1"/>
+                </a:solidFill>
+                <a:ea typeface="Calibri"/>
+                <a:cs typeface="Calibri"/>
               </a:rPr>
               <a:t>Adam</a:t>
             </a:r>
-            <a:endParaRPr lang="en-US">
-              <a:solidFill>
-                <a:schemeClr val="bg1"/>
-              </a:solidFill>
-              <a:ea typeface="Calibri"/>
-              <a:cs typeface="Calibri"/>
-            </a:endParaRPr>
           </a:p>
         </p:txBody>
       </p:sp>
@@ -10754,7 +11107,7 @@
           <a:lstStyle/>
           <a:p>
             <a:r>
-              <a:t>Why One Shared Repo</a:t>
+              <a:t>What We'll Do Today</a:t>
             </a:r>
           </a:p>
         </p:txBody>
@@ -10771,26 +11124,45 @@
         </p:nvSpPr>
         <p:spPr/>
         <p:txBody>
-          <a:bodyPr/>
+          <a:bodyPr>
+            <a:normAutofit fontScale="92500" lnSpcReduction="20000"/>
+          </a:bodyPr>
           <a:lstStyle/>
           <a:p>
             <a:r>
-              <a:t>Your TL cohort is building ONE platformer together.</a:t>
-            </a:r>
-          </a:p>
-          <a:p>
-            <a:r>
-              <a:t>Everyone adds at least one feature — and those features must merge into a single game.</a:t>
-            </a:r>
-          </a:p>
-          <a:p>
-            <a:r>
-              <a:t>Git lets several people contribute at once without overwriting each other's work.</a:t>
-            </a:r>
-          </a:p>
-          <a:p>
-            <a:r>
-              <a:t>TL1's job: set up the repo and teach the flow the rest of the team will use.</a:t>
+              <a:t>1  Why the team needs one shared repository</a:t>
+            </a:r>
+          </a:p>
+          <a:p>
+            <a:r>
+              <a:t>2  Two repos, two very different jobs</a:t>
+            </a:r>
+          </a:p>
+          <a:p>
+            <a:r>
+              <a:t>3  Follow Along 1: create the platformer repo (+ .</a:t>
+            </a:r>
+            <a:r>
+              <a:rPr err="1"/>
+              <a:t>gitignore</a:t>
+            </a:r>
+            <a:r>
+              <a:t>) and load the base game</a:t>
+            </a:r>
+          </a:p>
+          <a:p>
+            <a:r>
+              <a:t>4  Follow Along 2: cause and resolve merge conflicts (TEAM.md)</a:t>
+            </a:r>
+          </a:p>
+          <a:p>
+            <a:r>
+              <a:t>5  Follow Along 3: prove you can reach the locked project repo</a:t>
+            </a:r>
+          </a:p>
+          <a:p>
+            <a:r>
+              <a:t>6  The everyday loop, what to hand in, and how this runs during TL2</a:t>
             </a:r>
           </a:p>
         </p:txBody>
@@ -10800,7 +11172,7 @@
           <p:cNvPr id="4" name="TextBox 3">
             <a:extLst>
               <a:ext uri="{FF2B5EF4-FFF2-40B4-BE49-F238E27FC236}">
-                <a16:creationId xmlns:a16="http://schemas.microsoft.com/office/drawing/2014/main" id="{D874816A-4A80-1739-3717-90E7CE3C26B2}"/>
+                <a16:creationId xmlns:a16="http://schemas.microsoft.com/office/drawing/2014/main" id="{68D76FC4-A387-12B2-A548-3E07A9D18A62}"/>
               </a:ext>
             </a:extLst>
           </p:cNvPr>
@@ -10882,7 +11254,7 @@
           <a:lstStyle/>
           <a:p>
             <a:r>
-              <a:t>Two Repos, Two Jobs</a:t>
+              <a:t>Why One Shared Repo</a:t>
             </a:r>
           </a:p>
         </p:txBody>
@@ -10899,28 +11271,26 @@
         </p:nvSpPr>
         <p:spPr/>
         <p:txBody>
-          <a:bodyPr>
-            <a:normAutofit fontScale="85000" lnSpcReduction="10000"/>
-          </a:bodyPr>
+          <a:bodyPr/>
           <a:lstStyle/>
           <a:p>
             <a:r>
-              <a:t>PLATFORMER repo — our live workspace. Push, pull, and (on purpose today) hit merge conflicts. The one-directory ownership rule does NOT apply here.</a:t>
-            </a:r>
-          </a:p>
-          <a:p>
-            <a:r>
-              <a:t>MAIN PROJECT repo — your real project. Already set up, and LOCKED: no project code until the System's Analysis passes.</a:t>
-            </a:r>
-          </a:p>
-          <a:p>
-            <a:r>
-              <a:t>Today you touch the main repo for ONE thing: update your own README, to prove you can reach it.</a:t>
-            </a:r>
-          </a:p>
-          <a:p>
-            <a:r>
-              <a:t>All hands-on practice happens in the PLATFORMER repo. Don't run the drills on the locked repo.</a:t>
+              <a:t>Your TL cohort is building ONE platformer together.</a:t>
+            </a:r>
+          </a:p>
+          <a:p>
+            <a:r>
+              <a:t>Everyone adds at least one feature — and those features must merge into a single game.</a:t>
+            </a:r>
+          </a:p>
+          <a:p>
+            <a:r>
+              <a:t>Git lets several people contribute at once without overwriting each other's work.</a:t>
+            </a:r>
+          </a:p>
+          <a:p>
+            <a:r>
+              <a:t>TL1's job: set up the repo and teach the flow the rest of the team will use.</a:t>
             </a:r>
           </a:p>
         </p:txBody>
@@ -10930,7 +11300,7 @@
           <p:cNvPr id="4" name="TextBox 3">
             <a:extLst>
               <a:ext uri="{FF2B5EF4-FFF2-40B4-BE49-F238E27FC236}">
-                <a16:creationId xmlns:a16="http://schemas.microsoft.com/office/drawing/2014/main" id="{FF78575C-A48D-3D92-1B4B-BAD095B3A0BD}"/>
+                <a16:creationId xmlns:a16="http://schemas.microsoft.com/office/drawing/2014/main" id="{D874816A-4A80-1739-3717-90E7CE3C26B2}"/>
               </a:ext>
             </a:extLst>
           </p:cNvPr>
@@ -10958,11 +11328,16 @@
                 <a:solidFill>
                   <a:schemeClr val="bg1"/>
                 </a:solidFill>
-                <a:ea typeface="Calibri"/>
-                <a:cs typeface="Calibri"/>
               </a:rPr>
               <a:t>Adam</a:t>
             </a:r>
+            <a:endParaRPr lang="en-US">
+              <a:solidFill>
+                <a:schemeClr val="bg1"/>
+              </a:solidFill>
+              <a:ea typeface="Calibri"/>
+              <a:cs typeface="Calibri"/>
+            </a:endParaRPr>
           </a:p>
         </p:txBody>
       </p:sp>
@@ -10975,6 +11350,131 @@
 </file>
 
 <file path=ppt/slides/slide7.xml><?xml version="1.0" encoding="utf-8"?>
+<p:sld xmlns:a="http://schemas.openxmlformats.org/drawingml/2006/main" xmlns:r="http://schemas.openxmlformats.org/officeDocument/2006/relationships" xmlns:p="http://schemas.openxmlformats.org/presentationml/2006/main">
+  <p:cSld>
+    <p:spTree>
+      <p:nvGrpSpPr>
+        <p:cNvPr id="1" name=""/>
+        <p:cNvGrpSpPr/>
+        <p:nvPr/>
+      </p:nvGrpSpPr>
+      <p:grpSpPr>
+        <a:xfrm>
+          <a:off x="0" y="0"/>
+          <a:ext cx="0" cy="0"/>
+          <a:chOff x="0" y="0"/>
+          <a:chExt cx="0" cy="0"/>
+        </a:xfrm>
+      </p:grpSpPr>
+      <p:sp>
+        <p:nvSpPr>
+          <p:cNvPr id="2" name="Title 1"/>
+          <p:cNvSpPr>
+            <a:spLocks noGrp="1"/>
+          </p:cNvSpPr>
+          <p:nvPr>
+            <p:ph type="title"/>
+          </p:nvPr>
+        </p:nvSpPr>
+        <p:spPr/>
+        <p:txBody>
+          <a:bodyPr/>
+          <a:lstStyle/>
+          <a:p>
+            <a:r>
+              <a:t>Two Repos, Two Jobs</a:t>
+            </a:r>
+          </a:p>
+        </p:txBody>
+      </p:sp>
+      <p:sp>
+        <p:nvSpPr>
+          <p:cNvPr id="3" name="Content Placeholder 2"/>
+          <p:cNvSpPr>
+            <a:spLocks noGrp="1"/>
+          </p:cNvSpPr>
+          <p:nvPr>
+            <p:ph idx="1"/>
+          </p:nvPr>
+        </p:nvSpPr>
+        <p:spPr/>
+        <p:txBody>
+          <a:bodyPr>
+            <a:normAutofit fontScale="85000" lnSpcReduction="10000"/>
+          </a:bodyPr>
+          <a:lstStyle/>
+          <a:p>
+            <a:r>
+              <a:t>PLATFORMER repo — our live workspace. Push, pull, and (on purpose today) hit merge conflicts. The one-directory ownership rule does NOT apply here.</a:t>
+            </a:r>
+          </a:p>
+          <a:p>
+            <a:r>
+              <a:t>MAIN PROJECT repo — your real project. Already set up, and LOCKED: no project code until the System's Analysis passes.</a:t>
+            </a:r>
+          </a:p>
+          <a:p>
+            <a:r>
+              <a:t>Today you touch the main repo for ONE thing: update your own README, to prove you can reach it.</a:t>
+            </a:r>
+          </a:p>
+          <a:p>
+            <a:r>
+              <a:t>All hands-on practice happens in the PLATFORMER repo. Don't run the drills on the locked repo.</a:t>
+            </a:r>
+          </a:p>
+        </p:txBody>
+      </p:sp>
+      <p:sp>
+        <p:nvSpPr>
+          <p:cNvPr id="4" name="TextBox 3">
+            <a:extLst>
+              <a:ext uri="{FF2B5EF4-FFF2-40B4-BE49-F238E27FC236}">
+                <a16:creationId xmlns:a16="http://schemas.microsoft.com/office/drawing/2014/main" id="{FF78575C-A48D-3D92-1B4B-BAD095B3A0BD}"/>
+              </a:ext>
+            </a:extLst>
+          </p:cNvPr>
+          <p:cNvSpPr txBox="1"/>
+          <p:nvPr/>
+        </p:nvSpPr>
+        <p:spPr>
+          <a:xfrm>
+            <a:off x="457199" y="6583362"/>
+            <a:ext cx="2500010" cy="369332"/>
+          </a:xfrm>
+          <a:prstGeom prst="rect">
+            <a:avLst/>
+          </a:prstGeom>
+          <a:noFill/>
+        </p:spPr>
+        <p:txBody>
+          <a:bodyPr wrap="square" lIns="91440" tIns="45720" rIns="91440" bIns="45720" rtlCol="0" anchor="t">
+            <a:spAutoFit/>
+          </a:bodyPr>
+          <a:lstStyle/>
+          <a:p>
+            <a:r>
+              <a:rPr lang="en-US">
+                <a:solidFill>
+                  <a:schemeClr val="bg1"/>
+                </a:solidFill>
+                <a:ea typeface="Calibri"/>
+                <a:cs typeface="Calibri"/>
+              </a:rPr>
+              <a:t>Adam</a:t>
+            </a:r>
+          </a:p>
+        </p:txBody>
+      </p:sp>
+    </p:spTree>
+  </p:cSld>
+  <p:clrMapOvr>
+    <a:masterClrMapping/>
+  </p:clrMapOvr>
+</p:sld>
+</file>
+
+<file path=ppt/slides/slide8.xml><?xml version="1.0" encoding="utf-8"?>
 <p:sld xmlns:a="http://schemas.openxmlformats.org/drawingml/2006/main" xmlns:r="http://schemas.openxmlformats.org/officeDocument/2006/relationships" xmlns:p="http://schemas.openxmlformats.org/presentationml/2006/main">
   <p:cSld>
     <p:spTree>
@@ -11141,7 +11641,7 @@
 </p:sld>
 </file>
 
-<file path=ppt/slides/slide8.xml><?xml version="1.0" encoding="utf-8"?>
+<file path=ppt/slides/slide9.xml><?xml version="1.0" encoding="utf-8"?>
 <p:sld xmlns:a="http://schemas.openxmlformats.org/drawingml/2006/main" xmlns:r="http://schemas.openxmlformats.org/officeDocument/2006/relationships" xmlns:p="http://schemas.openxmlformats.org/presentationml/2006/main">
   <p:cSld>
     <p:spTree>
@@ -11295,166 +11795,6 @@
     <p:extLst>
       <p:ext uri="{BB962C8B-B14F-4D97-AF65-F5344CB8AC3E}">
         <p14:creationId xmlns:p14="http://schemas.microsoft.com/office/powerpoint/2010/main" val="188840435"/>
-      </p:ext>
-    </p:extLst>
-  </p:cSld>
-  <p:clrMapOvr>
-    <a:masterClrMapping/>
-  </p:clrMapOvr>
-</p:sld>
-</file>
-
-<file path=ppt/slides/slide9.xml><?xml version="1.0" encoding="utf-8"?>
-<p:sld xmlns:a="http://schemas.openxmlformats.org/drawingml/2006/main" xmlns:r="http://schemas.openxmlformats.org/officeDocument/2006/relationships" xmlns:p="http://schemas.openxmlformats.org/presentationml/2006/main">
-  <p:cSld>
-    <p:spTree>
-      <p:nvGrpSpPr>
-        <p:cNvPr id="1" name="">
-          <a:extLst>
-            <a:ext uri="{FF2B5EF4-FFF2-40B4-BE49-F238E27FC236}">
-              <a16:creationId xmlns:a16="http://schemas.microsoft.com/office/drawing/2014/main" id="{C39327F6-DFE2-67C3-A81E-95A338315303}"/>
-            </a:ext>
-          </a:extLst>
-        </p:cNvPr>
-        <p:cNvGrpSpPr/>
-        <p:nvPr/>
-      </p:nvGrpSpPr>
-      <p:grpSpPr>
-        <a:xfrm>
-          <a:off x="0" y="0"/>
-          <a:ext cx="0" cy="0"/>
-          <a:chOff x="0" y="0"/>
-          <a:chExt cx="0" cy="0"/>
-        </a:xfrm>
-      </p:grpSpPr>
-      <p:sp>
-        <p:nvSpPr>
-          <p:cNvPr id="2" name="Title 1">
-            <a:extLst>
-              <a:ext uri="{FF2B5EF4-FFF2-40B4-BE49-F238E27FC236}">
-                <a16:creationId xmlns:a16="http://schemas.microsoft.com/office/drawing/2014/main" id="{551426AD-7FD5-39AB-8D2E-F718E4E6F1F6}"/>
-              </a:ext>
-            </a:extLst>
-          </p:cNvPr>
-          <p:cNvSpPr>
-            <a:spLocks noGrp="1"/>
-          </p:cNvSpPr>
-          <p:nvPr>
-            <p:ph type="title"/>
-          </p:nvPr>
-        </p:nvSpPr>
-        <p:spPr/>
-        <p:txBody>
-          <a:bodyPr/>
-          <a:lstStyle/>
-          <a:p>
-            <a:r>
-              <a:rPr lang="en-US"/>
-              <a:t>Recap: Basic GIT commands</a:t>
-            </a:r>
-          </a:p>
-        </p:txBody>
-      </p:sp>
-      <p:sp>
-        <p:nvSpPr>
-          <p:cNvPr id="3" name="Content Placeholder 2">
-            <a:extLst>
-              <a:ext uri="{FF2B5EF4-FFF2-40B4-BE49-F238E27FC236}">
-                <a16:creationId xmlns:a16="http://schemas.microsoft.com/office/drawing/2014/main" id="{33347569-8C51-93EA-1945-52269F8EA7AE}"/>
-              </a:ext>
-            </a:extLst>
-          </p:cNvPr>
-          <p:cNvSpPr>
-            <a:spLocks noGrp="1"/>
-          </p:cNvSpPr>
-          <p:nvPr>
-            <p:ph idx="1"/>
-          </p:nvPr>
-        </p:nvSpPr>
-        <p:spPr/>
-        <p:txBody>
-          <a:bodyPr vert="horz" lIns="91440" tIns="45720" rIns="91440" bIns="45720" rtlCol="0" anchor="t">
-            <a:normAutofit/>
-          </a:bodyPr>
-          <a:lstStyle/>
-          <a:p>
-            <a:r>
-              <a:rPr lang="en-US">
-                <a:ea typeface="Calibri"/>
-                <a:cs typeface="Calibri"/>
-              </a:rPr>
-              <a:t>git push: Sends local commits to the remote repository. </a:t>
-            </a:r>
-          </a:p>
-          <a:p>
-            <a:r>
-              <a:rPr lang="en-US">
-                <a:ea typeface="Calibri"/>
-                <a:cs typeface="Calibri"/>
-              </a:rPr>
-              <a:t>git pull: Fetches new commits from remote branch and merges them with your local branch.</a:t>
-            </a:r>
-          </a:p>
-          <a:p>
-            <a:r>
-              <a:rPr lang="en-US">
-                <a:ea typeface="Calibri"/>
-                <a:cs typeface="Calibri"/>
-              </a:rPr>
-              <a:t>git merge: Takes changes from one branch and integrates them into another branch.</a:t>
-            </a:r>
-          </a:p>
-          <a:p>
-            <a:endParaRPr lang="en-US">
-              <a:ea typeface="Calibri"/>
-              <a:cs typeface="Calibri"/>
-            </a:endParaRPr>
-          </a:p>
-        </p:txBody>
-      </p:sp>
-      <p:sp>
-        <p:nvSpPr>
-          <p:cNvPr id="4" name="TextBox 3">
-            <a:extLst>
-              <a:ext uri="{FF2B5EF4-FFF2-40B4-BE49-F238E27FC236}">
-                <a16:creationId xmlns:a16="http://schemas.microsoft.com/office/drawing/2014/main" id="{424BBEFF-D94F-BCD7-3F59-E2978F9DD87B}"/>
-              </a:ext>
-            </a:extLst>
-          </p:cNvPr>
-          <p:cNvSpPr txBox="1"/>
-          <p:nvPr/>
-        </p:nvSpPr>
-        <p:spPr>
-          <a:xfrm>
-            <a:off x="457199" y="6583362"/>
-            <a:ext cx="2500010" cy="369332"/>
-          </a:xfrm>
-          <a:prstGeom prst="rect">
-            <a:avLst/>
-          </a:prstGeom>
-          <a:noFill/>
-        </p:spPr>
-        <p:txBody>
-          <a:bodyPr wrap="square" lIns="91440" tIns="45720" rIns="91440" bIns="45720" rtlCol="0" anchor="t">
-            <a:spAutoFit/>
-          </a:bodyPr>
-          <a:lstStyle/>
-          <a:p>
-            <a:r>
-              <a:rPr lang="en-US">
-                <a:solidFill>
-                  <a:schemeClr val="bg1"/>
-                </a:solidFill>
-              </a:rPr>
-              <a:t>Chris</a:t>
-            </a:r>
-          </a:p>
-        </p:txBody>
-      </p:sp>
-    </p:spTree>
-    <p:extLst>
-      <p:ext uri="{BB962C8B-B14F-4D97-AF65-F5344CB8AC3E}">
-        <p14:creationId xmlns:p14="http://schemas.microsoft.com/office/powerpoint/2010/main" val="2515922887"/>
       </p:ext>
     </p:extLst>
   </p:cSld>

</xml_diff>